<commit_message>
docs(apresentacoes): realce de sintaxe nos trechos de código
Blocos de código com as cores do tema padrão do VS Code (Dark Modern):
fundo #1F1F1F, palavras-chave, strings, números, comentários, funções,
tipos, constantes e colorização de pares de colchetes. Realce para CDS,
JavaScript, JSON, shell e requisições HTTP.

Co-Authored-By: Claude Opus 5.5 <noreply@anthropic.com>
</commit_message>
<xml_diff>
--- a/docs/apresentacoes/03-logica-de-negocio.pptx
+++ b/docs/apresentacoes/03-logica-de-negocio.pptx
@@ -119,43 +119,43 @@
   <p:extLst>
     <p:ext uri="{521415D9-36F7-43E2-AB2F-B90AF26B5E84}">
       <p14:sectionLst xmlns:p14="http://schemas.microsoft.com/office/powerpoint/2010/main">
-        <p14:section name="Abertura" id="{64229ae5-b53b-5b7b-afb0-c30fe61beaac}">
+        <p14:section name="Abertura" id="{7cfa2d05-8b3d-ef27-d097-7fb65d8c0516}">
           <p14:sldIdLst>
             <p14:sldId id="256"/>
           </p14:sldIdLst>
         </p14:section>
-        <p14:section name="Contexto" id="{6f5974c4-4289-3d8f-2c34-3ff8ecb80821}">
+        <p14:section name="Contexto" id="{0eec0615-33c0-fb4e-2feb-e1c7e6e6940c}">
           <p14:sldIdLst>
             <p14:sldId id="257"/>
           </p14:sldIdLst>
         </p14:section>
-        <p14:section name="Organização" id="{274f7668-0ebf-7b1a-e6f4-5981195f9737}">
+        <p14:section name="Organização" id="{fe987827-14cf-385f-635e-d84aaf4570a0}">
           <p14:sldIdLst>
             <p14:sldId id="258"/>
             <p14:sldId id="259"/>
           </p14:sldIdLst>
         </p14:section>
-        <p14:section name="Pedido e estoque" id="{1d8a57be-2433-0f6d-1ab9-66649defc260}">
+        <p14:section name="Pedido e estoque" id="{69d836ac-ce21-b5ba-c964-27ce6fac87d0}">
           <p14:sldIdLst>
             <p14:sldId id="260"/>
             <p14:sldId id="261"/>
             <p14:sldId id="262"/>
           </p14:sldIdLst>
         </p14:section>
-        <p14:section name="Pagamento e reembolso" id="{6f40c0de-649a-160b-0cac-c650a9938f35}">
+        <p14:section name="Pagamento e reembolso" id="{3438b81b-39b8-2311-9982-0003dc2019c6}">
           <p14:sldIdLst>
             <p14:sldId id="263"/>
             <p14:sldId id="264"/>
           </p14:sldIdLst>
         </p14:section>
-        <p14:section name="Integrações" id="{af403a6f-3a29-9656-a6bc-b7b447b8050e}">
+        <p14:section name="Integrações" id="{b3e215ff-51f0-1de1-1924-9594fc61681c}">
           <p14:sldIdLst>
             <p14:sldId id="265"/>
             <p14:sldId id="266"/>
             <p14:sldId id="267"/>
           </p14:sldIdLst>
         </p14:section>
-        <p14:section name="Encerramento" id="{a5d42f42-ceb7-da6e-7493-02b44dd1480b}">
+        <p14:section name="Encerramento" id="{c98b34aa-dece-c9b3-e9f6-56198ce00ba4}">
           <p14:sldIdLst>
             <p14:sldId id="268"/>
           </p14:sldIdLst>
@@ -9125,9 +9125,14 @@
             </a:avLst>
           </a:prstGeom>
           <a:solidFill>
-            <a:srgbClr val="1D2D3E"/>
+            <a:srgbClr val="1F1F1F"/>
           </a:solidFill>
-          <a:ln/>
+          <a:ln w="9525">
+            <a:solidFill>
+              <a:srgbClr val="2B2B2B"/>
+            </a:solidFill>
+            <a:prstDash val="solid"/>
+          </a:ln>
           <a:effectLst>
             <a:outerShdw sx="100000" sy="100000" kx="0" ky="0" algn="bl" rotWithShape="0" blurRad="101600" dist="25400" dir="5400000">
               <a:srgbClr val="223649">
@@ -9164,13 +9169,97 @@
             <a:r>
               <a:rPr lang="en-US" sz="1200" dirty="0">
                 <a:solidFill>
-                  <a:srgbClr val="EAECEE"/>
-                </a:solidFill>
-                <a:latin typeface="Courier New" pitchFamily="34" charset="0"/>
-                <a:ea typeface="Courier New" pitchFamily="34" charset="-122"/>
-                <a:cs typeface="Courier New" pitchFamily="34" charset="-120"/>
-              </a:rPr>
-              <a:t>export default class PedidosService</a:t>
+                  <a:srgbClr val="C586C0"/>
+                </a:solidFill>
+                <a:latin typeface="Courier New" pitchFamily="34" charset="0"/>
+                <a:ea typeface="Courier New" pitchFamily="34" charset="-122"/>
+                <a:cs typeface="Courier New" pitchFamily="34" charset="-120"/>
+              </a:rPr>
+              <a:t>export</a:t>
+            </a:r>
+            <a:pPr indent="0" marL="0">
+              <a:buNone/>
+            </a:pPr>
+            <a:r>
+              <a:rPr lang="en-US" sz="1200" dirty="0">
+                <a:solidFill>
+                  <a:srgbClr val="CCCCCC"/>
+                </a:solidFill>
+                <a:latin typeface="Courier New" pitchFamily="34" charset="0"/>
+                <a:ea typeface="Courier New" pitchFamily="34" charset="-122"/>
+                <a:cs typeface="Courier New" pitchFamily="34" charset="-120"/>
+              </a:rPr>
+              <a:t> </a:t>
+            </a:r>
+            <a:pPr indent="0" marL="0">
+              <a:buNone/>
+            </a:pPr>
+            <a:r>
+              <a:rPr lang="en-US" sz="1200" dirty="0">
+                <a:solidFill>
+                  <a:srgbClr val="C586C0"/>
+                </a:solidFill>
+                <a:latin typeface="Courier New" pitchFamily="34" charset="0"/>
+                <a:ea typeface="Courier New" pitchFamily="34" charset="-122"/>
+                <a:cs typeface="Courier New" pitchFamily="34" charset="-120"/>
+              </a:rPr>
+              <a:t>default</a:t>
+            </a:r>
+            <a:pPr indent="0" marL="0">
+              <a:buNone/>
+            </a:pPr>
+            <a:r>
+              <a:rPr lang="en-US" sz="1200" dirty="0">
+                <a:solidFill>
+                  <a:srgbClr val="CCCCCC"/>
+                </a:solidFill>
+                <a:latin typeface="Courier New" pitchFamily="34" charset="0"/>
+                <a:ea typeface="Courier New" pitchFamily="34" charset="-122"/>
+                <a:cs typeface="Courier New" pitchFamily="34" charset="-120"/>
+              </a:rPr>
+              <a:t> </a:t>
+            </a:r>
+            <a:pPr indent="0" marL="0">
+              <a:buNone/>
+            </a:pPr>
+            <a:r>
+              <a:rPr lang="en-US" sz="1200" dirty="0">
+                <a:solidFill>
+                  <a:srgbClr val="569CD6"/>
+                </a:solidFill>
+                <a:latin typeface="Courier New" pitchFamily="34" charset="0"/>
+                <a:ea typeface="Courier New" pitchFamily="34" charset="-122"/>
+                <a:cs typeface="Courier New" pitchFamily="34" charset="-120"/>
+              </a:rPr>
+              <a:t>class</a:t>
+            </a:r>
+            <a:pPr indent="0" marL="0">
+              <a:buNone/>
+            </a:pPr>
+            <a:r>
+              <a:rPr lang="en-US" sz="1200" dirty="0">
+                <a:solidFill>
+                  <a:srgbClr val="CCCCCC"/>
+                </a:solidFill>
+                <a:latin typeface="Courier New" pitchFamily="34" charset="0"/>
+                <a:ea typeface="Courier New" pitchFamily="34" charset="-122"/>
+                <a:cs typeface="Courier New" pitchFamily="34" charset="-120"/>
+              </a:rPr>
+              <a:t> </a:t>
+            </a:r>
+            <a:pPr indent="0" marL="0">
+              <a:buNone/>
+            </a:pPr>
+            <a:r>
+              <a:rPr lang="en-US" sz="1200" dirty="0">
+                <a:solidFill>
+                  <a:srgbClr val="4EC9B0"/>
+                </a:solidFill>
+                <a:latin typeface="Courier New" pitchFamily="34" charset="0"/>
+                <a:ea typeface="Courier New" pitchFamily="34" charset="-122"/>
+                <a:cs typeface="Courier New" pitchFamily="34" charset="-120"/>
+              </a:rPr>
+              <a:t>PedidosService</a:t>
             </a:r>
             <a:endParaRPr lang="en-US" sz="1200" dirty="0"/>
           </a:p>
@@ -9181,13 +9270,111 @@
             <a:r>
               <a:rPr lang="en-US" sz="1200" dirty="0">
                 <a:solidFill>
-                  <a:srgbClr val="EAECEE"/>
-                </a:solidFill>
-                <a:latin typeface="Courier New" pitchFamily="34" charset="0"/>
-                <a:ea typeface="Courier New" pitchFamily="34" charset="-122"/>
-                <a:cs typeface="Courier New" pitchFamily="34" charset="-120"/>
-              </a:rPr>
-              <a:t>  extends cds.ApplicationService {</a:t>
+                  <a:srgbClr val="CCCCCC"/>
+                </a:solidFill>
+                <a:latin typeface="Courier New" pitchFamily="34" charset="0"/>
+                <a:ea typeface="Courier New" pitchFamily="34" charset="-122"/>
+                <a:cs typeface="Courier New" pitchFamily="34" charset="-120"/>
+              </a:rPr>
+              <a:t>  </a:t>
+            </a:r>
+            <a:pPr indent="0" marL="0">
+              <a:buNone/>
+            </a:pPr>
+            <a:r>
+              <a:rPr lang="en-US" sz="1200" dirty="0">
+                <a:solidFill>
+                  <a:srgbClr val="569CD6"/>
+                </a:solidFill>
+                <a:latin typeface="Courier New" pitchFamily="34" charset="0"/>
+                <a:ea typeface="Courier New" pitchFamily="34" charset="-122"/>
+                <a:cs typeface="Courier New" pitchFamily="34" charset="-120"/>
+              </a:rPr>
+              <a:t>extends</a:t>
+            </a:r>
+            <a:pPr indent="0" marL="0">
+              <a:buNone/>
+            </a:pPr>
+            <a:r>
+              <a:rPr lang="en-US" sz="1200" dirty="0">
+                <a:solidFill>
+                  <a:srgbClr val="CCCCCC"/>
+                </a:solidFill>
+                <a:latin typeface="Courier New" pitchFamily="34" charset="0"/>
+                <a:ea typeface="Courier New" pitchFamily="34" charset="-122"/>
+                <a:cs typeface="Courier New" pitchFamily="34" charset="-120"/>
+              </a:rPr>
+              <a:t> </a:t>
+            </a:r>
+            <a:pPr indent="0" marL="0">
+              <a:buNone/>
+            </a:pPr>
+            <a:r>
+              <a:rPr lang="en-US" sz="1200" dirty="0">
+                <a:solidFill>
+                  <a:srgbClr val="9CDCFE"/>
+                </a:solidFill>
+                <a:latin typeface="Courier New" pitchFamily="34" charset="0"/>
+                <a:ea typeface="Courier New" pitchFamily="34" charset="-122"/>
+                <a:cs typeface="Courier New" pitchFamily="34" charset="-120"/>
+              </a:rPr>
+              <a:t>cds</a:t>
+            </a:r>
+            <a:pPr indent="0" marL="0">
+              <a:buNone/>
+            </a:pPr>
+            <a:r>
+              <a:rPr lang="en-US" sz="1200" dirty="0">
+                <a:solidFill>
+                  <a:srgbClr val="CCCCCC"/>
+                </a:solidFill>
+                <a:latin typeface="Courier New" pitchFamily="34" charset="0"/>
+                <a:ea typeface="Courier New" pitchFamily="34" charset="-122"/>
+                <a:cs typeface="Courier New" pitchFamily="34" charset="-120"/>
+              </a:rPr>
+              <a:t>.</a:t>
+            </a:r>
+            <a:pPr indent="0" marL="0">
+              <a:buNone/>
+            </a:pPr>
+            <a:r>
+              <a:rPr lang="en-US" sz="1200" dirty="0">
+                <a:solidFill>
+                  <a:srgbClr val="4EC9B0"/>
+                </a:solidFill>
+                <a:latin typeface="Courier New" pitchFamily="34" charset="0"/>
+                <a:ea typeface="Courier New" pitchFamily="34" charset="-122"/>
+                <a:cs typeface="Courier New" pitchFamily="34" charset="-120"/>
+              </a:rPr>
+              <a:t>ApplicationService</a:t>
+            </a:r>
+            <a:pPr indent="0" marL="0">
+              <a:buNone/>
+            </a:pPr>
+            <a:r>
+              <a:rPr lang="en-US" sz="1200" dirty="0">
+                <a:solidFill>
+                  <a:srgbClr val="CCCCCC"/>
+                </a:solidFill>
+                <a:latin typeface="Courier New" pitchFamily="34" charset="0"/>
+                <a:ea typeface="Courier New" pitchFamily="34" charset="-122"/>
+                <a:cs typeface="Courier New" pitchFamily="34" charset="-120"/>
+              </a:rPr>
+              <a:t> </a:t>
+            </a:r>
+            <a:pPr indent="0" marL="0">
+              <a:buNone/>
+            </a:pPr>
+            <a:r>
+              <a:rPr lang="en-US" sz="1200" dirty="0">
+                <a:solidFill>
+                  <a:srgbClr val="FFD700"/>
+                </a:solidFill>
+                <a:latin typeface="Courier New" pitchFamily="34" charset="0"/>
+                <a:ea typeface="Courier New" pitchFamily="34" charset="-122"/>
+                <a:cs typeface="Courier New" pitchFamily="34" charset="-120"/>
+              </a:rPr>
+              <a:t>{</a:t>
             </a:r>
             <a:endParaRPr lang="en-US" sz="1200" dirty="0"/>
           </a:p>
@@ -9198,13 +9385,69 @@
             <a:r>
               <a:rPr lang="en-US" sz="1200" dirty="0">
                 <a:solidFill>
-                  <a:srgbClr val="EAECEE"/>
-                </a:solidFill>
-                <a:latin typeface="Courier New" pitchFamily="34" charset="0"/>
-                <a:ea typeface="Courier New" pitchFamily="34" charset="-122"/>
-                <a:cs typeface="Courier New" pitchFamily="34" charset="-120"/>
-              </a:rPr>
-              <a:t>  init() {</a:t>
+                  <a:srgbClr val="CCCCCC"/>
+                </a:solidFill>
+                <a:latin typeface="Courier New" pitchFamily="34" charset="0"/>
+                <a:ea typeface="Courier New" pitchFamily="34" charset="-122"/>
+                <a:cs typeface="Courier New" pitchFamily="34" charset="-120"/>
+              </a:rPr>
+              <a:t>  </a:t>
+            </a:r>
+            <a:pPr indent="0" marL="0">
+              <a:buNone/>
+            </a:pPr>
+            <a:r>
+              <a:rPr lang="en-US" sz="1200" dirty="0">
+                <a:solidFill>
+                  <a:srgbClr val="DCDCAA"/>
+                </a:solidFill>
+                <a:latin typeface="Courier New" pitchFamily="34" charset="0"/>
+                <a:ea typeface="Courier New" pitchFamily="34" charset="-122"/>
+                <a:cs typeface="Courier New" pitchFamily="34" charset="-120"/>
+              </a:rPr>
+              <a:t>init</a:t>
+            </a:r>
+            <a:pPr indent="0" marL="0">
+              <a:buNone/>
+            </a:pPr>
+            <a:r>
+              <a:rPr lang="en-US" sz="1200" dirty="0">
+                <a:solidFill>
+                  <a:srgbClr val="DA70D6"/>
+                </a:solidFill>
+                <a:latin typeface="Courier New" pitchFamily="34" charset="0"/>
+                <a:ea typeface="Courier New" pitchFamily="34" charset="-122"/>
+                <a:cs typeface="Courier New" pitchFamily="34" charset="-120"/>
+              </a:rPr>
+              <a:t>()</a:t>
+            </a:r>
+            <a:pPr indent="0" marL="0">
+              <a:buNone/>
+            </a:pPr>
+            <a:r>
+              <a:rPr lang="en-US" sz="1200" dirty="0">
+                <a:solidFill>
+                  <a:srgbClr val="CCCCCC"/>
+                </a:solidFill>
+                <a:latin typeface="Courier New" pitchFamily="34" charset="0"/>
+                <a:ea typeface="Courier New" pitchFamily="34" charset="-122"/>
+                <a:cs typeface="Courier New" pitchFamily="34" charset="-120"/>
+              </a:rPr>
+              <a:t> </a:t>
+            </a:r>
+            <a:pPr indent="0" marL="0">
+              <a:buNone/>
+            </a:pPr>
+            <a:r>
+              <a:rPr lang="en-US" sz="1200" dirty="0">
+                <a:solidFill>
+                  <a:srgbClr val="DA70D6"/>
+                </a:solidFill>
+                <a:latin typeface="Courier New" pitchFamily="34" charset="0"/>
+                <a:ea typeface="Courier New" pitchFamily="34" charset="-122"/>
+                <a:cs typeface="Courier New" pitchFamily="34" charset="-120"/>
+              </a:rPr>
+              <a:t>{</a:t>
             </a:r>
             <a:endParaRPr lang="en-US" sz="1200" dirty="0"/>
           </a:p>
@@ -9215,13 +9458,195 @@
             <a:r>
               <a:rPr lang="en-US" sz="1200" dirty="0">
                 <a:solidFill>
-                  <a:srgbClr val="EAECEE"/>
-                </a:solidFill>
-                <a:latin typeface="Courier New" pitchFamily="34" charset="0"/>
-                <a:ea typeface="Courier New" pitchFamily="34" charset="-122"/>
-                <a:cs typeface="Courier New" pitchFamily="34" charset="-120"/>
-              </a:rPr>
-              <a:t>    const { Pedidos, ItensPedido } = this.entities</a:t>
+                  <a:srgbClr val="CCCCCC"/>
+                </a:solidFill>
+                <a:latin typeface="Courier New" pitchFamily="34" charset="0"/>
+                <a:ea typeface="Courier New" pitchFamily="34" charset="-122"/>
+                <a:cs typeface="Courier New" pitchFamily="34" charset="-120"/>
+              </a:rPr>
+              <a:t>    </a:t>
+            </a:r>
+            <a:pPr indent="0" marL="0">
+              <a:buNone/>
+            </a:pPr>
+            <a:r>
+              <a:rPr lang="en-US" sz="1200" dirty="0">
+                <a:solidFill>
+                  <a:srgbClr val="569CD6"/>
+                </a:solidFill>
+                <a:latin typeface="Courier New" pitchFamily="34" charset="0"/>
+                <a:ea typeface="Courier New" pitchFamily="34" charset="-122"/>
+                <a:cs typeface="Courier New" pitchFamily="34" charset="-120"/>
+              </a:rPr>
+              <a:t>const</a:t>
+            </a:r>
+            <a:pPr indent="0" marL="0">
+              <a:buNone/>
+            </a:pPr>
+            <a:r>
+              <a:rPr lang="en-US" sz="1200" dirty="0">
+                <a:solidFill>
+                  <a:srgbClr val="CCCCCC"/>
+                </a:solidFill>
+                <a:latin typeface="Courier New" pitchFamily="34" charset="0"/>
+                <a:ea typeface="Courier New" pitchFamily="34" charset="-122"/>
+                <a:cs typeface="Courier New" pitchFamily="34" charset="-120"/>
+              </a:rPr>
+              <a:t> </a:t>
+            </a:r>
+            <a:pPr indent="0" marL="0">
+              <a:buNone/>
+            </a:pPr>
+            <a:r>
+              <a:rPr lang="en-US" sz="1200" dirty="0">
+                <a:solidFill>
+                  <a:srgbClr val="179FFF"/>
+                </a:solidFill>
+                <a:latin typeface="Courier New" pitchFamily="34" charset="0"/>
+                <a:ea typeface="Courier New" pitchFamily="34" charset="-122"/>
+                <a:cs typeface="Courier New" pitchFamily="34" charset="-120"/>
+              </a:rPr>
+              <a:t>{</a:t>
+            </a:r>
+            <a:pPr indent="0" marL="0">
+              <a:buNone/>
+            </a:pPr>
+            <a:r>
+              <a:rPr lang="en-US" sz="1200" dirty="0">
+                <a:solidFill>
+                  <a:srgbClr val="CCCCCC"/>
+                </a:solidFill>
+                <a:latin typeface="Courier New" pitchFamily="34" charset="0"/>
+                <a:ea typeface="Courier New" pitchFamily="34" charset="-122"/>
+                <a:cs typeface="Courier New" pitchFamily="34" charset="-120"/>
+              </a:rPr>
+              <a:t> </a:t>
+            </a:r>
+            <a:pPr indent="0" marL="0">
+              <a:buNone/>
+            </a:pPr>
+            <a:r>
+              <a:rPr lang="en-US" sz="1200" dirty="0">
+                <a:solidFill>
+                  <a:srgbClr val="4EC9B0"/>
+                </a:solidFill>
+                <a:latin typeface="Courier New" pitchFamily="34" charset="0"/>
+                <a:ea typeface="Courier New" pitchFamily="34" charset="-122"/>
+                <a:cs typeface="Courier New" pitchFamily="34" charset="-120"/>
+              </a:rPr>
+              <a:t>Pedidos</a:t>
+            </a:r>
+            <a:pPr indent="0" marL="0">
+              <a:buNone/>
+            </a:pPr>
+            <a:r>
+              <a:rPr lang="en-US" sz="1200" dirty="0">
+                <a:solidFill>
+                  <a:srgbClr val="CCCCCC"/>
+                </a:solidFill>
+                <a:latin typeface="Courier New" pitchFamily="34" charset="0"/>
+                <a:ea typeface="Courier New" pitchFamily="34" charset="-122"/>
+                <a:cs typeface="Courier New" pitchFamily="34" charset="-120"/>
+              </a:rPr>
+              <a:t>, </a:t>
+            </a:r>
+            <a:pPr indent="0" marL="0">
+              <a:buNone/>
+            </a:pPr>
+            <a:r>
+              <a:rPr lang="en-US" sz="1200" dirty="0">
+                <a:solidFill>
+                  <a:srgbClr val="4EC9B0"/>
+                </a:solidFill>
+                <a:latin typeface="Courier New" pitchFamily="34" charset="0"/>
+                <a:ea typeface="Courier New" pitchFamily="34" charset="-122"/>
+                <a:cs typeface="Courier New" pitchFamily="34" charset="-120"/>
+              </a:rPr>
+              <a:t>ItensPedido</a:t>
+            </a:r>
+            <a:pPr indent="0" marL="0">
+              <a:buNone/>
+            </a:pPr>
+            <a:r>
+              <a:rPr lang="en-US" sz="1200" dirty="0">
+                <a:solidFill>
+                  <a:srgbClr val="CCCCCC"/>
+                </a:solidFill>
+                <a:latin typeface="Courier New" pitchFamily="34" charset="0"/>
+                <a:ea typeface="Courier New" pitchFamily="34" charset="-122"/>
+                <a:cs typeface="Courier New" pitchFamily="34" charset="-120"/>
+              </a:rPr>
+              <a:t> </a:t>
+            </a:r>
+            <a:pPr indent="0" marL="0">
+              <a:buNone/>
+            </a:pPr>
+            <a:r>
+              <a:rPr lang="en-US" sz="1200" dirty="0">
+                <a:solidFill>
+                  <a:srgbClr val="179FFF"/>
+                </a:solidFill>
+                <a:latin typeface="Courier New" pitchFamily="34" charset="0"/>
+                <a:ea typeface="Courier New" pitchFamily="34" charset="-122"/>
+                <a:cs typeface="Courier New" pitchFamily="34" charset="-120"/>
+              </a:rPr>
+              <a:t>}</a:t>
+            </a:r>
+            <a:pPr indent="0" marL="0">
+              <a:buNone/>
+            </a:pPr>
+            <a:r>
+              <a:rPr lang="en-US" sz="1200" dirty="0">
+                <a:solidFill>
+                  <a:srgbClr val="CCCCCC"/>
+                </a:solidFill>
+                <a:latin typeface="Courier New" pitchFamily="34" charset="0"/>
+                <a:ea typeface="Courier New" pitchFamily="34" charset="-122"/>
+                <a:cs typeface="Courier New" pitchFamily="34" charset="-120"/>
+              </a:rPr>
+              <a:t> = </a:t>
+            </a:r>
+            <a:pPr indent="0" marL="0">
+              <a:buNone/>
+            </a:pPr>
+            <a:r>
+              <a:rPr lang="en-US" sz="1200" dirty="0">
+                <a:solidFill>
+                  <a:srgbClr val="569CD6"/>
+                </a:solidFill>
+                <a:latin typeface="Courier New" pitchFamily="34" charset="0"/>
+                <a:ea typeface="Courier New" pitchFamily="34" charset="-122"/>
+                <a:cs typeface="Courier New" pitchFamily="34" charset="-120"/>
+              </a:rPr>
+              <a:t>this</a:t>
+            </a:r>
+            <a:pPr indent="0" marL="0">
+              <a:buNone/>
+            </a:pPr>
+            <a:r>
+              <a:rPr lang="en-US" sz="1200" dirty="0">
+                <a:solidFill>
+                  <a:srgbClr val="CCCCCC"/>
+                </a:solidFill>
+                <a:latin typeface="Courier New" pitchFamily="34" charset="0"/>
+                <a:ea typeface="Courier New" pitchFamily="34" charset="-122"/>
+                <a:cs typeface="Courier New" pitchFamily="34" charset="-120"/>
+              </a:rPr>
+              <a:t>.</a:t>
+            </a:r>
+            <a:pPr indent="0" marL="0">
+              <a:buNone/>
+            </a:pPr>
+            <a:r>
+              <a:rPr lang="en-US" sz="1200" dirty="0">
+                <a:solidFill>
+                  <a:srgbClr val="9CDCFE"/>
+                </a:solidFill>
+                <a:latin typeface="Courier New" pitchFamily="34" charset="0"/>
+                <a:ea typeface="Courier New" pitchFamily="34" charset="-122"/>
+                <a:cs typeface="Courier New" pitchFamily="34" charset="-120"/>
+              </a:rPr>
+              <a:t>entities</a:t>
             </a:r>
             <a:endParaRPr lang="en-US" sz="1200" dirty="0"/>
           </a:p>
@@ -9232,7 +9657,7 @@
             <a:r>
               <a:rPr lang="en-US" sz="1200" dirty="0">
                 <a:solidFill>
-                  <a:srgbClr val="EAECEE"/>
+                  <a:srgbClr val="CCCCCC"/>
                 </a:solidFill>
                 <a:latin typeface="Courier New" pitchFamily="34" charset="0"/>
                 <a:ea typeface="Courier New" pitchFamily="34" charset="-122"/>
@@ -9249,13 +9674,27 @@
             <a:r>
               <a:rPr lang="en-US" sz="1200" dirty="0">
                 <a:solidFill>
-                  <a:srgbClr val="A9B4BE"/>
-                </a:solidFill>
-                <a:latin typeface="Courier New" pitchFamily="34" charset="0"/>
-                <a:ea typeface="Courier New" pitchFamily="34" charset="-122"/>
-                <a:cs typeface="Courier New" pitchFamily="34" charset="-120"/>
-              </a:rPr>
-              <a:t>    // Rascunho novo: status e moeda iniciais</a:t>
+                  <a:srgbClr val="CCCCCC"/>
+                </a:solidFill>
+                <a:latin typeface="Courier New" pitchFamily="34" charset="0"/>
+                <a:ea typeface="Courier New" pitchFamily="34" charset="-122"/>
+                <a:cs typeface="Courier New" pitchFamily="34" charset="-120"/>
+              </a:rPr>
+              <a:t>    </a:t>
+            </a:r>
+            <a:pPr indent="0" marL="0">
+              <a:buNone/>
+            </a:pPr>
+            <a:r>
+              <a:rPr lang="en-US" sz="1200" dirty="0">
+                <a:solidFill>
+                  <a:srgbClr val="6A9955"/>
+                </a:solidFill>
+                <a:latin typeface="Courier New" pitchFamily="34" charset="0"/>
+                <a:ea typeface="Courier New" pitchFamily="34" charset="-122"/>
+                <a:cs typeface="Courier New" pitchFamily="34" charset="-120"/>
+              </a:rPr>
+              <a:t>// Rascunho novo: status e moeda iniciais</a:t>
             </a:r>
             <a:endParaRPr lang="en-US" sz="1200" dirty="0"/>
           </a:p>
@@ -9266,13 +9705,195 @@
             <a:r>
               <a:rPr lang="en-US" sz="1200" dirty="0">
                 <a:solidFill>
-                  <a:srgbClr val="EAECEE"/>
-                </a:solidFill>
-                <a:latin typeface="Courier New" pitchFamily="34" charset="0"/>
-                <a:ea typeface="Courier New" pitchFamily="34" charset="-122"/>
-                <a:cs typeface="Courier New" pitchFamily="34" charset="-120"/>
-              </a:rPr>
-              <a:t>    this.before('NEW', Pedidos.drafts, req =&gt; {</a:t>
+                  <a:srgbClr val="CCCCCC"/>
+                </a:solidFill>
+                <a:latin typeface="Courier New" pitchFamily="34" charset="0"/>
+                <a:ea typeface="Courier New" pitchFamily="34" charset="-122"/>
+                <a:cs typeface="Courier New" pitchFamily="34" charset="-120"/>
+              </a:rPr>
+              <a:t>    </a:t>
+            </a:r>
+            <a:pPr indent="0" marL="0">
+              <a:buNone/>
+            </a:pPr>
+            <a:r>
+              <a:rPr lang="en-US" sz="1200" dirty="0">
+                <a:solidFill>
+                  <a:srgbClr val="569CD6"/>
+                </a:solidFill>
+                <a:latin typeface="Courier New" pitchFamily="34" charset="0"/>
+                <a:ea typeface="Courier New" pitchFamily="34" charset="-122"/>
+                <a:cs typeface="Courier New" pitchFamily="34" charset="-120"/>
+              </a:rPr>
+              <a:t>this</a:t>
+            </a:r>
+            <a:pPr indent="0" marL="0">
+              <a:buNone/>
+            </a:pPr>
+            <a:r>
+              <a:rPr lang="en-US" sz="1200" dirty="0">
+                <a:solidFill>
+                  <a:srgbClr val="CCCCCC"/>
+                </a:solidFill>
+                <a:latin typeface="Courier New" pitchFamily="34" charset="0"/>
+                <a:ea typeface="Courier New" pitchFamily="34" charset="-122"/>
+                <a:cs typeface="Courier New" pitchFamily="34" charset="-120"/>
+              </a:rPr>
+              <a:t>.</a:t>
+            </a:r>
+            <a:pPr indent="0" marL="0">
+              <a:buNone/>
+            </a:pPr>
+            <a:r>
+              <a:rPr lang="en-US" sz="1200" dirty="0">
+                <a:solidFill>
+                  <a:srgbClr val="DCDCAA"/>
+                </a:solidFill>
+                <a:latin typeface="Courier New" pitchFamily="34" charset="0"/>
+                <a:ea typeface="Courier New" pitchFamily="34" charset="-122"/>
+                <a:cs typeface="Courier New" pitchFamily="34" charset="-120"/>
+              </a:rPr>
+              <a:t>before</a:t>
+            </a:r>
+            <a:pPr indent="0" marL="0">
+              <a:buNone/>
+            </a:pPr>
+            <a:r>
+              <a:rPr lang="en-US" sz="1200" dirty="0">
+                <a:solidFill>
+                  <a:srgbClr val="179FFF"/>
+                </a:solidFill>
+                <a:latin typeface="Courier New" pitchFamily="34" charset="0"/>
+                <a:ea typeface="Courier New" pitchFamily="34" charset="-122"/>
+                <a:cs typeface="Courier New" pitchFamily="34" charset="-120"/>
+              </a:rPr>
+              <a:t>(</a:t>
+            </a:r>
+            <a:pPr indent="0" marL="0">
+              <a:buNone/>
+            </a:pPr>
+            <a:r>
+              <a:rPr lang="en-US" sz="1200" dirty="0">
+                <a:solidFill>
+                  <a:srgbClr val="CE9178"/>
+                </a:solidFill>
+                <a:latin typeface="Courier New" pitchFamily="34" charset="0"/>
+                <a:ea typeface="Courier New" pitchFamily="34" charset="-122"/>
+                <a:cs typeface="Courier New" pitchFamily="34" charset="-120"/>
+              </a:rPr>
+              <a:t>'NEW'</a:t>
+            </a:r>
+            <a:pPr indent="0" marL="0">
+              <a:buNone/>
+            </a:pPr>
+            <a:r>
+              <a:rPr lang="en-US" sz="1200" dirty="0">
+                <a:solidFill>
+                  <a:srgbClr val="CCCCCC"/>
+                </a:solidFill>
+                <a:latin typeface="Courier New" pitchFamily="34" charset="0"/>
+                <a:ea typeface="Courier New" pitchFamily="34" charset="-122"/>
+                <a:cs typeface="Courier New" pitchFamily="34" charset="-120"/>
+              </a:rPr>
+              <a:t>, </a:t>
+            </a:r>
+            <a:pPr indent="0" marL="0">
+              <a:buNone/>
+            </a:pPr>
+            <a:r>
+              <a:rPr lang="en-US" sz="1200" dirty="0">
+                <a:solidFill>
+                  <a:srgbClr val="4EC9B0"/>
+                </a:solidFill>
+                <a:latin typeface="Courier New" pitchFamily="34" charset="0"/>
+                <a:ea typeface="Courier New" pitchFamily="34" charset="-122"/>
+                <a:cs typeface="Courier New" pitchFamily="34" charset="-120"/>
+              </a:rPr>
+              <a:t>Pedidos</a:t>
+            </a:r>
+            <a:pPr indent="0" marL="0">
+              <a:buNone/>
+            </a:pPr>
+            <a:r>
+              <a:rPr lang="en-US" sz="1200" dirty="0">
+                <a:solidFill>
+                  <a:srgbClr val="CCCCCC"/>
+                </a:solidFill>
+                <a:latin typeface="Courier New" pitchFamily="34" charset="0"/>
+                <a:ea typeface="Courier New" pitchFamily="34" charset="-122"/>
+                <a:cs typeface="Courier New" pitchFamily="34" charset="-120"/>
+              </a:rPr>
+              <a:t>.</a:t>
+            </a:r>
+            <a:pPr indent="0" marL="0">
+              <a:buNone/>
+            </a:pPr>
+            <a:r>
+              <a:rPr lang="en-US" sz="1200" dirty="0">
+                <a:solidFill>
+                  <a:srgbClr val="9CDCFE"/>
+                </a:solidFill>
+                <a:latin typeface="Courier New" pitchFamily="34" charset="0"/>
+                <a:ea typeface="Courier New" pitchFamily="34" charset="-122"/>
+                <a:cs typeface="Courier New" pitchFamily="34" charset="-120"/>
+              </a:rPr>
+              <a:t>drafts</a:t>
+            </a:r>
+            <a:pPr indent="0" marL="0">
+              <a:buNone/>
+            </a:pPr>
+            <a:r>
+              <a:rPr lang="en-US" sz="1200" dirty="0">
+                <a:solidFill>
+                  <a:srgbClr val="CCCCCC"/>
+                </a:solidFill>
+                <a:latin typeface="Courier New" pitchFamily="34" charset="0"/>
+                <a:ea typeface="Courier New" pitchFamily="34" charset="-122"/>
+                <a:cs typeface="Courier New" pitchFamily="34" charset="-120"/>
+              </a:rPr>
+              <a:t>, </a:t>
+            </a:r>
+            <a:pPr indent="0" marL="0">
+              <a:buNone/>
+            </a:pPr>
+            <a:r>
+              <a:rPr lang="en-US" sz="1200" dirty="0">
+                <a:solidFill>
+                  <a:srgbClr val="9CDCFE"/>
+                </a:solidFill>
+                <a:latin typeface="Courier New" pitchFamily="34" charset="0"/>
+                <a:ea typeface="Courier New" pitchFamily="34" charset="-122"/>
+                <a:cs typeface="Courier New" pitchFamily="34" charset="-120"/>
+              </a:rPr>
+              <a:t>req</a:t>
+            </a:r>
+            <a:pPr indent="0" marL="0">
+              <a:buNone/>
+            </a:pPr>
+            <a:r>
+              <a:rPr lang="en-US" sz="1200" dirty="0">
+                <a:solidFill>
+                  <a:srgbClr val="CCCCCC"/>
+                </a:solidFill>
+                <a:latin typeface="Courier New" pitchFamily="34" charset="0"/>
+                <a:ea typeface="Courier New" pitchFamily="34" charset="-122"/>
+                <a:cs typeface="Courier New" pitchFamily="34" charset="-120"/>
+              </a:rPr>
+              <a:t> =&gt; </a:t>
+            </a:r>
+            <a:pPr indent="0" marL="0">
+              <a:buNone/>
+            </a:pPr>
+            <a:r>
+              <a:rPr lang="en-US" sz="1200" dirty="0">
+                <a:solidFill>
+                  <a:srgbClr val="FFD700"/>
+                </a:solidFill>
+                <a:latin typeface="Courier New" pitchFamily="34" charset="0"/>
+                <a:ea typeface="Courier New" pitchFamily="34" charset="-122"/>
+                <a:cs typeface="Courier New" pitchFamily="34" charset="-120"/>
+              </a:rPr>
+              <a:t>{</a:t>
             </a:r>
             <a:endParaRPr lang="en-US" sz="1200" dirty="0"/>
           </a:p>
@@ -9283,13 +9904,139 @@
             <a:r>
               <a:rPr lang="en-US" sz="1200" dirty="0">
                 <a:solidFill>
-                  <a:srgbClr val="EAECEE"/>
-                </a:solidFill>
-                <a:latin typeface="Courier New" pitchFamily="34" charset="0"/>
-                <a:ea typeface="Courier New" pitchFamily="34" charset="-122"/>
-                <a:cs typeface="Courier New" pitchFamily="34" charset="-120"/>
-              </a:rPr>
-              <a:t>      Object.assign(req.data, {</a:t>
+                  <a:srgbClr val="CCCCCC"/>
+                </a:solidFill>
+                <a:latin typeface="Courier New" pitchFamily="34" charset="0"/>
+                <a:ea typeface="Courier New" pitchFamily="34" charset="-122"/>
+                <a:cs typeface="Courier New" pitchFamily="34" charset="-120"/>
+              </a:rPr>
+              <a:t>      </a:t>
+            </a:r>
+            <a:pPr indent="0" marL="0">
+              <a:buNone/>
+            </a:pPr>
+            <a:r>
+              <a:rPr lang="en-US" sz="1200" dirty="0">
+                <a:solidFill>
+                  <a:srgbClr val="4EC9B0"/>
+                </a:solidFill>
+                <a:latin typeface="Courier New" pitchFamily="34" charset="0"/>
+                <a:ea typeface="Courier New" pitchFamily="34" charset="-122"/>
+                <a:cs typeface="Courier New" pitchFamily="34" charset="-120"/>
+              </a:rPr>
+              <a:t>Object</a:t>
+            </a:r>
+            <a:pPr indent="0" marL="0">
+              <a:buNone/>
+            </a:pPr>
+            <a:r>
+              <a:rPr lang="en-US" sz="1200" dirty="0">
+                <a:solidFill>
+                  <a:srgbClr val="CCCCCC"/>
+                </a:solidFill>
+                <a:latin typeface="Courier New" pitchFamily="34" charset="0"/>
+                <a:ea typeface="Courier New" pitchFamily="34" charset="-122"/>
+                <a:cs typeface="Courier New" pitchFamily="34" charset="-120"/>
+              </a:rPr>
+              <a:t>.</a:t>
+            </a:r>
+            <a:pPr indent="0" marL="0">
+              <a:buNone/>
+            </a:pPr>
+            <a:r>
+              <a:rPr lang="en-US" sz="1200" dirty="0">
+                <a:solidFill>
+                  <a:srgbClr val="DCDCAA"/>
+                </a:solidFill>
+                <a:latin typeface="Courier New" pitchFamily="34" charset="0"/>
+                <a:ea typeface="Courier New" pitchFamily="34" charset="-122"/>
+                <a:cs typeface="Courier New" pitchFamily="34" charset="-120"/>
+              </a:rPr>
+              <a:t>assign</a:t>
+            </a:r>
+            <a:pPr indent="0" marL="0">
+              <a:buNone/>
+            </a:pPr>
+            <a:r>
+              <a:rPr lang="en-US" sz="1200" dirty="0">
+                <a:solidFill>
+                  <a:srgbClr val="DA70D6"/>
+                </a:solidFill>
+                <a:latin typeface="Courier New" pitchFamily="34" charset="0"/>
+                <a:ea typeface="Courier New" pitchFamily="34" charset="-122"/>
+                <a:cs typeface="Courier New" pitchFamily="34" charset="-120"/>
+              </a:rPr>
+              <a:t>(</a:t>
+            </a:r>
+            <a:pPr indent="0" marL="0">
+              <a:buNone/>
+            </a:pPr>
+            <a:r>
+              <a:rPr lang="en-US" sz="1200" dirty="0">
+                <a:solidFill>
+                  <a:srgbClr val="9CDCFE"/>
+                </a:solidFill>
+                <a:latin typeface="Courier New" pitchFamily="34" charset="0"/>
+                <a:ea typeface="Courier New" pitchFamily="34" charset="-122"/>
+                <a:cs typeface="Courier New" pitchFamily="34" charset="-120"/>
+              </a:rPr>
+              <a:t>req</a:t>
+            </a:r>
+            <a:pPr indent="0" marL="0">
+              <a:buNone/>
+            </a:pPr>
+            <a:r>
+              <a:rPr lang="en-US" sz="1200" dirty="0">
+                <a:solidFill>
+                  <a:srgbClr val="CCCCCC"/>
+                </a:solidFill>
+                <a:latin typeface="Courier New" pitchFamily="34" charset="0"/>
+                <a:ea typeface="Courier New" pitchFamily="34" charset="-122"/>
+                <a:cs typeface="Courier New" pitchFamily="34" charset="-120"/>
+              </a:rPr>
+              <a:t>.</a:t>
+            </a:r>
+            <a:pPr indent="0" marL="0">
+              <a:buNone/>
+            </a:pPr>
+            <a:r>
+              <a:rPr lang="en-US" sz="1200" dirty="0">
+                <a:solidFill>
+                  <a:srgbClr val="9CDCFE"/>
+                </a:solidFill>
+                <a:latin typeface="Courier New" pitchFamily="34" charset="0"/>
+                <a:ea typeface="Courier New" pitchFamily="34" charset="-122"/>
+                <a:cs typeface="Courier New" pitchFamily="34" charset="-120"/>
+              </a:rPr>
+              <a:t>data</a:t>
+            </a:r>
+            <a:pPr indent="0" marL="0">
+              <a:buNone/>
+            </a:pPr>
+            <a:r>
+              <a:rPr lang="en-US" sz="1200" dirty="0">
+                <a:solidFill>
+                  <a:srgbClr val="CCCCCC"/>
+                </a:solidFill>
+                <a:latin typeface="Courier New" pitchFamily="34" charset="0"/>
+                <a:ea typeface="Courier New" pitchFamily="34" charset="-122"/>
+                <a:cs typeface="Courier New" pitchFamily="34" charset="-120"/>
+              </a:rPr>
+              <a:t>, </a:t>
+            </a:r>
+            <a:pPr indent="0" marL="0">
+              <a:buNone/>
+            </a:pPr>
+            <a:r>
+              <a:rPr lang="en-US" sz="1200" dirty="0">
+                <a:solidFill>
+                  <a:srgbClr val="179FFF"/>
+                </a:solidFill>
+                <a:latin typeface="Courier New" pitchFamily="34" charset="0"/>
+                <a:ea typeface="Courier New" pitchFamily="34" charset="-122"/>
+                <a:cs typeface="Courier New" pitchFamily="34" charset="-120"/>
+              </a:rPr>
+              <a:t>{</a:t>
             </a:r>
             <a:endParaRPr lang="en-US" sz="1200" dirty="0"/>
           </a:p>
@@ -9300,13 +10047,97 @@
             <a:r>
               <a:rPr lang="en-US" sz="1200" dirty="0">
                 <a:solidFill>
-                  <a:srgbClr val="EAECEE"/>
-                </a:solidFill>
-                <a:latin typeface="Courier New" pitchFamily="34" charset="0"/>
-                <a:ea typeface="Courier New" pitchFamily="34" charset="-122"/>
-                <a:cs typeface="Courier New" pitchFamily="34" charset="-120"/>
-              </a:rPr>
-              <a:t>        statusPedido_code: STATUS.aberto,</a:t>
+                  <a:srgbClr val="CCCCCC"/>
+                </a:solidFill>
+                <a:latin typeface="Courier New" pitchFamily="34" charset="0"/>
+                <a:ea typeface="Courier New" pitchFamily="34" charset="-122"/>
+                <a:cs typeface="Courier New" pitchFamily="34" charset="-120"/>
+              </a:rPr>
+              <a:t>        </a:t>
+            </a:r>
+            <a:pPr indent="0" marL="0">
+              <a:buNone/>
+            </a:pPr>
+            <a:r>
+              <a:rPr lang="en-US" sz="1200" dirty="0">
+                <a:solidFill>
+                  <a:srgbClr val="9CDCFE"/>
+                </a:solidFill>
+                <a:latin typeface="Courier New" pitchFamily="34" charset="0"/>
+                <a:ea typeface="Courier New" pitchFamily="34" charset="-122"/>
+                <a:cs typeface="Courier New" pitchFamily="34" charset="-120"/>
+              </a:rPr>
+              <a:t>statusPedido_code</a:t>
+            </a:r>
+            <a:pPr indent="0" marL="0">
+              <a:buNone/>
+            </a:pPr>
+            <a:r>
+              <a:rPr lang="en-US" sz="1200" dirty="0">
+                <a:solidFill>
+                  <a:srgbClr val="CCCCCC"/>
+                </a:solidFill>
+                <a:latin typeface="Courier New" pitchFamily="34" charset="0"/>
+                <a:ea typeface="Courier New" pitchFamily="34" charset="-122"/>
+                <a:cs typeface="Courier New" pitchFamily="34" charset="-120"/>
+              </a:rPr>
+              <a:t>: </a:t>
+            </a:r>
+            <a:pPr indent="0" marL="0">
+              <a:buNone/>
+            </a:pPr>
+            <a:r>
+              <a:rPr lang="en-US" sz="1200" dirty="0">
+                <a:solidFill>
+                  <a:srgbClr val="4FC1FF"/>
+                </a:solidFill>
+                <a:latin typeface="Courier New" pitchFamily="34" charset="0"/>
+                <a:ea typeface="Courier New" pitchFamily="34" charset="-122"/>
+                <a:cs typeface="Courier New" pitchFamily="34" charset="-120"/>
+              </a:rPr>
+              <a:t>STATUS</a:t>
+            </a:r>
+            <a:pPr indent="0" marL="0">
+              <a:buNone/>
+            </a:pPr>
+            <a:r>
+              <a:rPr lang="en-US" sz="1200" dirty="0">
+                <a:solidFill>
+                  <a:srgbClr val="CCCCCC"/>
+                </a:solidFill>
+                <a:latin typeface="Courier New" pitchFamily="34" charset="0"/>
+                <a:ea typeface="Courier New" pitchFamily="34" charset="-122"/>
+                <a:cs typeface="Courier New" pitchFamily="34" charset="-120"/>
+              </a:rPr>
+              <a:t>.</a:t>
+            </a:r>
+            <a:pPr indent="0" marL="0">
+              <a:buNone/>
+            </a:pPr>
+            <a:r>
+              <a:rPr lang="en-US" sz="1200" dirty="0">
+                <a:solidFill>
+                  <a:srgbClr val="9CDCFE"/>
+                </a:solidFill>
+                <a:latin typeface="Courier New" pitchFamily="34" charset="0"/>
+                <a:ea typeface="Courier New" pitchFamily="34" charset="-122"/>
+                <a:cs typeface="Courier New" pitchFamily="34" charset="-120"/>
+              </a:rPr>
+              <a:t>aberto</a:t>
+            </a:r>
+            <a:pPr indent="0" marL="0">
+              <a:buNone/>
+            </a:pPr>
+            <a:r>
+              <a:rPr lang="en-US" sz="1200" dirty="0">
+                <a:solidFill>
+                  <a:srgbClr val="CCCCCC"/>
+                </a:solidFill>
+                <a:latin typeface="Courier New" pitchFamily="34" charset="0"/>
+                <a:ea typeface="Courier New" pitchFamily="34" charset="-122"/>
+                <a:cs typeface="Courier New" pitchFamily="34" charset="-120"/>
+              </a:rPr>
+              <a:t>,</a:t>
             </a:r>
             <a:endParaRPr lang="en-US" sz="1200" dirty="0"/>
           </a:p>
@@ -9317,13 +10148,97 @@
             <a:r>
               <a:rPr lang="en-US" sz="1200" dirty="0">
                 <a:solidFill>
-                  <a:srgbClr val="EAECEE"/>
-                </a:solidFill>
-                <a:latin typeface="Courier New" pitchFamily="34" charset="0"/>
-                <a:ea typeface="Courier New" pitchFamily="34" charset="-122"/>
-                <a:cs typeface="Courier New" pitchFamily="34" charset="-120"/>
-              </a:rPr>
-              <a:t>        statusPagamento_code: STATUS_PAGAMENTO.pendente,</a:t>
+                  <a:srgbClr val="CCCCCC"/>
+                </a:solidFill>
+                <a:latin typeface="Courier New" pitchFamily="34" charset="0"/>
+                <a:ea typeface="Courier New" pitchFamily="34" charset="-122"/>
+                <a:cs typeface="Courier New" pitchFamily="34" charset="-120"/>
+              </a:rPr>
+              <a:t>        </a:t>
+            </a:r>
+            <a:pPr indent="0" marL="0">
+              <a:buNone/>
+            </a:pPr>
+            <a:r>
+              <a:rPr lang="en-US" sz="1200" dirty="0">
+                <a:solidFill>
+                  <a:srgbClr val="9CDCFE"/>
+                </a:solidFill>
+                <a:latin typeface="Courier New" pitchFamily="34" charset="0"/>
+                <a:ea typeface="Courier New" pitchFamily="34" charset="-122"/>
+                <a:cs typeface="Courier New" pitchFamily="34" charset="-120"/>
+              </a:rPr>
+              <a:t>statusPagamento_code</a:t>
+            </a:r>
+            <a:pPr indent="0" marL="0">
+              <a:buNone/>
+            </a:pPr>
+            <a:r>
+              <a:rPr lang="en-US" sz="1200" dirty="0">
+                <a:solidFill>
+                  <a:srgbClr val="CCCCCC"/>
+                </a:solidFill>
+                <a:latin typeface="Courier New" pitchFamily="34" charset="0"/>
+                <a:ea typeface="Courier New" pitchFamily="34" charset="-122"/>
+                <a:cs typeface="Courier New" pitchFamily="34" charset="-120"/>
+              </a:rPr>
+              <a:t>: </a:t>
+            </a:r>
+            <a:pPr indent="0" marL="0">
+              <a:buNone/>
+            </a:pPr>
+            <a:r>
+              <a:rPr lang="en-US" sz="1200" dirty="0">
+                <a:solidFill>
+                  <a:srgbClr val="4FC1FF"/>
+                </a:solidFill>
+                <a:latin typeface="Courier New" pitchFamily="34" charset="0"/>
+                <a:ea typeface="Courier New" pitchFamily="34" charset="-122"/>
+                <a:cs typeface="Courier New" pitchFamily="34" charset="-120"/>
+              </a:rPr>
+              <a:t>STATUS_PAGAMENTO</a:t>
+            </a:r>
+            <a:pPr indent="0" marL="0">
+              <a:buNone/>
+            </a:pPr>
+            <a:r>
+              <a:rPr lang="en-US" sz="1200" dirty="0">
+                <a:solidFill>
+                  <a:srgbClr val="CCCCCC"/>
+                </a:solidFill>
+                <a:latin typeface="Courier New" pitchFamily="34" charset="0"/>
+                <a:ea typeface="Courier New" pitchFamily="34" charset="-122"/>
+                <a:cs typeface="Courier New" pitchFamily="34" charset="-120"/>
+              </a:rPr>
+              <a:t>.</a:t>
+            </a:r>
+            <a:pPr indent="0" marL="0">
+              <a:buNone/>
+            </a:pPr>
+            <a:r>
+              <a:rPr lang="en-US" sz="1200" dirty="0">
+                <a:solidFill>
+                  <a:srgbClr val="9CDCFE"/>
+                </a:solidFill>
+                <a:latin typeface="Courier New" pitchFamily="34" charset="0"/>
+                <a:ea typeface="Courier New" pitchFamily="34" charset="-122"/>
+                <a:cs typeface="Courier New" pitchFamily="34" charset="-120"/>
+              </a:rPr>
+              <a:t>pendente</a:t>
+            </a:r>
+            <a:pPr indent="0" marL="0">
+              <a:buNone/>
+            </a:pPr>
+            <a:r>
+              <a:rPr lang="en-US" sz="1200" dirty="0">
+                <a:solidFill>
+                  <a:srgbClr val="CCCCCC"/>
+                </a:solidFill>
+                <a:latin typeface="Courier New" pitchFamily="34" charset="0"/>
+                <a:ea typeface="Courier New" pitchFamily="34" charset="-122"/>
+                <a:cs typeface="Courier New" pitchFamily="34" charset="-120"/>
+              </a:rPr>
+              <a:t>,</a:t>
             </a:r>
             <a:endParaRPr lang="en-US" sz="1200" dirty="0"/>
           </a:p>
@@ -9334,13 +10249,153 @@
             <a:r>
               <a:rPr lang="en-US" sz="1200" dirty="0">
                 <a:solidFill>
-                  <a:srgbClr val="EAECEE"/>
-                </a:solidFill>
-                <a:latin typeface="Courier New" pitchFamily="34" charset="0"/>
-                <a:ea typeface="Courier New" pitchFamily="34" charset="-122"/>
-                <a:cs typeface="Courier New" pitchFamily="34" charset="-120"/>
-              </a:rPr>
-              <a:t>        currency_code: MOEDA_PADRAO, valorTotal: 0 })</a:t>
+                  <a:srgbClr val="CCCCCC"/>
+                </a:solidFill>
+                <a:latin typeface="Courier New" pitchFamily="34" charset="0"/>
+                <a:ea typeface="Courier New" pitchFamily="34" charset="-122"/>
+                <a:cs typeface="Courier New" pitchFamily="34" charset="-120"/>
+              </a:rPr>
+              <a:t>        </a:t>
+            </a:r>
+            <a:pPr indent="0" marL="0">
+              <a:buNone/>
+            </a:pPr>
+            <a:r>
+              <a:rPr lang="en-US" sz="1200" dirty="0">
+                <a:solidFill>
+                  <a:srgbClr val="9CDCFE"/>
+                </a:solidFill>
+                <a:latin typeface="Courier New" pitchFamily="34" charset="0"/>
+                <a:ea typeface="Courier New" pitchFamily="34" charset="-122"/>
+                <a:cs typeface="Courier New" pitchFamily="34" charset="-120"/>
+              </a:rPr>
+              <a:t>currency_code</a:t>
+            </a:r>
+            <a:pPr indent="0" marL="0">
+              <a:buNone/>
+            </a:pPr>
+            <a:r>
+              <a:rPr lang="en-US" sz="1200" dirty="0">
+                <a:solidFill>
+                  <a:srgbClr val="CCCCCC"/>
+                </a:solidFill>
+                <a:latin typeface="Courier New" pitchFamily="34" charset="0"/>
+                <a:ea typeface="Courier New" pitchFamily="34" charset="-122"/>
+                <a:cs typeface="Courier New" pitchFamily="34" charset="-120"/>
+              </a:rPr>
+              <a:t>: </a:t>
+            </a:r>
+            <a:pPr indent="0" marL="0">
+              <a:buNone/>
+            </a:pPr>
+            <a:r>
+              <a:rPr lang="en-US" sz="1200" dirty="0">
+                <a:solidFill>
+                  <a:srgbClr val="4FC1FF"/>
+                </a:solidFill>
+                <a:latin typeface="Courier New" pitchFamily="34" charset="0"/>
+                <a:ea typeface="Courier New" pitchFamily="34" charset="-122"/>
+                <a:cs typeface="Courier New" pitchFamily="34" charset="-120"/>
+              </a:rPr>
+              <a:t>MOEDA_PADRAO</a:t>
+            </a:r>
+            <a:pPr indent="0" marL="0">
+              <a:buNone/>
+            </a:pPr>
+            <a:r>
+              <a:rPr lang="en-US" sz="1200" dirty="0">
+                <a:solidFill>
+                  <a:srgbClr val="CCCCCC"/>
+                </a:solidFill>
+                <a:latin typeface="Courier New" pitchFamily="34" charset="0"/>
+                <a:ea typeface="Courier New" pitchFamily="34" charset="-122"/>
+                <a:cs typeface="Courier New" pitchFamily="34" charset="-120"/>
+              </a:rPr>
+              <a:t>, </a:t>
+            </a:r>
+            <a:pPr indent="0" marL="0">
+              <a:buNone/>
+            </a:pPr>
+            <a:r>
+              <a:rPr lang="en-US" sz="1200" dirty="0">
+                <a:solidFill>
+                  <a:srgbClr val="9CDCFE"/>
+                </a:solidFill>
+                <a:latin typeface="Courier New" pitchFamily="34" charset="0"/>
+                <a:ea typeface="Courier New" pitchFamily="34" charset="-122"/>
+                <a:cs typeface="Courier New" pitchFamily="34" charset="-120"/>
+              </a:rPr>
+              <a:t>valorTotal</a:t>
+            </a:r>
+            <a:pPr indent="0" marL="0">
+              <a:buNone/>
+            </a:pPr>
+            <a:r>
+              <a:rPr lang="en-US" sz="1200" dirty="0">
+                <a:solidFill>
+                  <a:srgbClr val="CCCCCC"/>
+                </a:solidFill>
+                <a:latin typeface="Courier New" pitchFamily="34" charset="0"/>
+                <a:ea typeface="Courier New" pitchFamily="34" charset="-122"/>
+                <a:cs typeface="Courier New" pitchFamily="34" charset="-120"/>
+              </a:rPr>
+              <a:t>: </a:t>
+            </a:r>
+            <a:pPr indent="0" marL="0">
+              <a:buNone/>
+            </a:pPr>
+            <a:r>
+              <a:rPr lang="en-US" sz="1200" dirty="0">
+                <a:solidFill>
+                  <a:srgbClr val="B5CEA8"/>
+                </a:solidFill>
+                <a:latin typeface="Courier New" pitchFamily="34" charset="0"/>
+                <a:ea typeface="Courier New" pitchFamily="34" charset="-122"/>
+                <a:cs typeface="Courier New" pitchFamily="34" charset="-120"/>
+              </a:rPr>
+              <a:t>0</a:t>
+            </a:r>
+            <a:pPr indent="0" marL="0">
+              <a:buNone/>
+            </a:pPr>
+            <a:r>
+              <a:rPr lang="en-US" sz="1200" dirty="0">
+                <a:solidFill>
+                  <a:srgbClr val="CCCCCC"/>
+                </a:solidFill>
+                <a:latin typeface="Courier New" pitchFamily="34" charset="0"/>
+                <a:ea typeface="Courier New" pitchFamily="34" charset="-122"/>
+                <a:cs typeface="Courier New" pitchFamily="34" charset="-120"/>
+              </a:rPr>
+              <a:t> </a:t>
+            </a:r>
+            <a:pPr indent="0" marL="0">
+              <a:buNone/>
+            </a:pPr>
+            <a:r>
+              <a:rPr lang="en-US" sz="1200" dirty="0">
+                <a:solidFill>
+                  <a:srgbClr val="179FFF"/>
+                </a:solidFill>
+                <a:latin typeface="Courier New" pitchFamily="34" charset="0"/>
+                <a:ea typeface="Courier New" pitchFamily="34" charset="-122"/>
+                <a:cs typeface="Courier New" pitchFamily="34" charset="-120"/>
+              </a:rPr>
+              <a:t>}</a:t>
+            </a:r>
+            <a:pPr indent="0" marL="0">
+              <a:buNone/>
+            </a:pPr>
+            <a:r>
+              <a:rPr lang="en-US" sz="1200" dirty="0">
+                <a:solidFill>
+                  <a:srgbClr val="DA70D6"/>
+                </a:solidFill>
+                <a:latin typeface="Courier New" pitchFamily="34" charset="0"/>
+                <a:ea typeface="Courier New" pitchFamily="34" charset="-122"/>
+                <a:cs typeface="Courier New" pitchFamily="34" charset="-120"/>
+              </a:rPr>
+              <a:t>)</a:t>
             </a:r>
             <a:endParaRPr lang="en-US" sz="1200" dirty="0"/>
           </a:p>
@@ -9351,13 +10406,41 @@
             <a:r>
               <a:rPr lang="en-US" sz="1200" dirty="0">
                 <a:solidFill>
-                  <a:srgbClr val="EAECEE"/>
-                </a:solidFill>
-                <a:latin typeface="Courier New" pitchFamily="34" charset="0"/>
-                <a:ea typeface="Courier New" pitchFamily="34" charset="-122"/>
-                <a:cs typeface="Courier New" pitchFamily="34" charset="-120"/>
-              </a:rPr>
-              <a:t>    })</a:t>
+                  <a:srgbClr val="CCCCCC"/>
+                </a:solidFill>
+                <a:latin typeface="Courier New" pitchFamily="34" charset="0"/>
+                <a:ea typeface="Courier New" pitchFamily="34" charset="-122"/>
+                <a:cs typeface="Courier New" pitchFamily="34" charset="-120"/>
+              </a:rPr>
+              <a:t>    </a:t>
+            </a:r>
+            <a:pPr indent="0" marL="0">
+              <a:buNone/>
+            </a:pPr>
+            <a:r>
+              <a:rPr lang="en-US" sz="1200" dirty="0">
+                <a:solidFill>
+                  <a:srgbClr val="FFD700"/>
+                </a:solidFill>
+                <a:latin typeface="Courier New" pitchFamily="34" charset="0"/>
+                <a:ea typeface="Courier New" pitchFamily="34" charset="-122"/>
+                <a:cs typeface="Courier New" pitchFamily="34" charset="-120"/>
+              </a:rPr>
+              <a:t>}</a:t>
+            </a:r>
+            <a:pPr indent="0" marL="0">
+              <a:buNone/>
+            </a:pPr>
+            <a:r>
+              <a:rPr lang="en-US" sz="1200" dirty="0">
+                <a:solidFill>
+                  <a:srgbClr val="179FFF"/>
+                </a:solidFill>
+                <a:latin typeface="Courier New" pitchFamily="34" charset="0"/>
+                <a:ea typeface="Courier New" pitchFamily="34" charset="-122"/>
+                <a:cs typeface="Courier New" pitchFamily="34" charset="-120"/>
+              </a:rPr>
+              <a:t>)</a:t>
             </a:r>
             <a:endParaRPr lang="en-US" sz="1200" dirty="0"/>
           </a:p>
@@ -9368,7 +10451,7 @@
             <a:r>
               <a:rPr lang="en-US" sz="1200" dirty="0">
                 <a:solidFill>
-                  <a:srgbClr val="EAECEE"/>
+                  <a:srgbClr val="CCCCCC"/>
                 </a:solidFill>
                 <a:latin typeface="Courier New" pitchFamily="34" charset="0"/>
                 <a:ea typeface="Courier New" pitchFamily="34" charset="-122"/>
@@ -9385,13 +10468,27 @@
             <a:r>
               <a:rPr lang="en-US" sz="1200" dirty="0">
                 <a:solidFill>
-                  <a:srgbClr val="A9B4BE"/>
-                </a:solidFill>
-                <a:latin typeface="Courier New" pitchFamily="34" charset="0"/>
-                <a:ea typeface="Courier New" pitchFamily="34" charset="-122"/>
-                <a:cs typeface="Courier New" pitchFamily="34" charset="-120"/>
-              </a:rPr>
-              <a:t>    // Troca de cliente: endereço principal atual</a:t>
+                  <a:srgbClr val="CCCCCC"/>
+                </a:solidFill>
+                <a:latin typeface="Courier New" pitchFamily="34" charset="0"/>
+                <a:ea typeface="Courier New" pitchFamily="34" charset="-122"/>
+                <a:cs typeface="Courier New" pitchFamily="34" charset="-120"/>
+              </a:rPr>
+              <a:t>    </a:t>
+            </a:r>
+            <a:pPr indent="0" marL="0">
+              <a:buNone/>
+            </a:pPr>
+            <a:r>
+              <a:rPr lang="en-US" sz="1200" dirty="0">
+                <a:solidFill>
+                  <a:srgbClr val="6A9955"/>
+                </a:solidFill>
+                <a:latin typeface="Courier New" pitchFamily="34" charset="0"/>
+                <a:ea typeface="Courier New" pitchFamily="34" charset="-122"/>
+                <a:cs typeface="Courier New" pitchFamily="34" charset="-120"/>
+              </a:rPr>
+              <a:t>// Troca de cliente: endereço principal atual</a:t>
             </a:r>
             <a:endParaRPr lang="en-US" sz="1200" dirty="0"/>
           </a:p>
@@ -9402,13 +10499,223 @@
             <a:r>
               <a:rPr lang="en-US" sz="1200" dirty="0">
                 <a:solidFill>
-                  <a:srgbClr val="EAECEE"/>
-                </a:solidFill>
-                <a:latin typeface="Courier New" pitchFamily="34" charset="0"/>
-                <a:ea typeface="Courier New" pitchFamily="34" charset="-122"/>
-                <a:cs typeface="Courier New" pitchFamily="34" charset="-120"/>
-              </a:rPr>
-              <a:t>    this.before('PATCH', Pedidos.drafts, async req =&gt; {</a:t>
+                  <a:srgbClr val="CCCCCC"/>
+                </a:solidFill>
+                <a:latin typeface="Courier New" pitchFamily="34" charset="0"/>
+                <a:ea typeface="Courier New" pitchFamily="34" charset="-122"/>
+                <a:cs typeface="Courier New" pitchFamily="34" charset="-120"/>
+              </a:rPr>
+              <a:t>    </a:t>
+            </a:r>
+            <a:pPr indent="0" marL="0">
+              <a:buNone/>
+            </a:pPr>
+            <a:r>
+              <a:rPr lang="en-US" sz="1200" dirty="0">
+                <a:solidFill>
+                  <a:srgbClr val="569CD6"/>
+                </a:solidFill>
+                <a:latin typeface="Courier New" pitchFamily="34" charset="0"/>
+                <a:ea typeface="Courier New" pitchFamily="34" charset="-122"/>
+                <a:cs typeface="Courier New" pitchFamily="34" charset="-120"/>
+              </a:rPr>
+              <a:t>this</a:t>
+            </a:r>
+            <a:pPr indent="0" marL="0">
+              <a:buNone/>
+            </a:pPr>
+            <a:r>
+              <a:rPr lang="en-US" sz="1200" dirty="0">
+                <a:solidFill>
+                  <a:srgbClr val="CCCCCC"/>
+                </a:solidFill>
+                <a:latin typeface="Courier New" pitchFamily="34" charset="0"/>
+                <a:ea typeface="Courier New" pitchFamily="34" charset="-122"/>
+                <a:cs typeface="Courier New" pitchFamily="34" charset="-120"/>
+              </a:rPr>
+              <a:t>.</a:t>
+            </a:r>
+            <a:pPr indent="0" marL="0">
+              <a:buNone/>
+            </a:pPr>
+            <a:r>
+              <a:rPr lang="en-US" sz="1200" dirty="0">
+                <a:solidFill>
+                  <a:srgbClr val="DCDCAA"/>
+                </a:solidFill>
+                <a:latin typeface="Courier New" pitchFamily="34" charset="0"/>
+                <a:ea typeface="Courier New" pitchFamily="34" charset="-122"/>
+                <a:cs typeface="Courier New" pitchFamily="34" charset="-120"/>
+              </a:rPr>
+              <a:t>before</a:t>
+            </a:r>
+            <a:pPr indent="0" marL="0">
+              <a:buNone/>
+            </a:pPr>
+            <a:r>
+              <a:rPr lang="en-US" sz="1200" dirty="0">
+                <a:solidFill>
+                  <a:srgbClr val="179FFF"/>
+                </a:solidFill>
+                <a:latin typeface="Courier New" pitchFamily="34" charset="0"/>
+                <a:ea typeface="Courier New" pitchFamily="34" charset="-122"/>
+                <a:cs typeface="Courier New" pitchFamily="34" charset="-120"/>
+              </a:rPr>
+              <a:t>(</a:t>
+            </a:r>
+            <a:pPr indent="0" marL="0">
+              <a:buNone/>
+            </a:pPr>
+            <a:r>
+              <a:rPr lang="en-US" sz="1200" dirty="0">
+                <a:solidFill>
+                  <a:srgbClr val="CE9178"/>
+                </a:solidFill>
+                <a:latin typeface="Courier New" pitchFamily="34" charset="0"/>
+                <a:ea typeface="Courier New" pitchFamily="34" charset="-122"/>
+                <a:cs typeface="Courier New" pitchFamily="34" charset="-120"/>
+              </a:rPr>
+              <a:t>'PATCH'</a:t>
+            </a:r>
+            <a:pPr indent="0" marL="0">
+              <a:buNone/>
+            </a:pPr>
+            <a:r>
+              <a:rPr lang="en-US" sz="1200" dirty="0">
+                <a:solidFill>
+                  <a:srgbClr val="CCCCCC"/>
+                </a:solidFill>
+                <a:latin typeface="Courier New" pitchFamily="34" charset="0"/>
+                <a:ea typeface="Courier New" pitchFamily="34" charset="-122"/>
+                <a:cs typeface="Courier New" pitchFamily="34" charset="-120"/>
+              </a:rPr>
+              <a:t>, </a:t>
+            </a:r>
+            <a:pPr indent="0" marL="0">
+              <a:buNone/>
+            </a:pPr>
+            <a:r>
+              <a:rPr lang="en-US" sz="1200" dirty="0">
+                <a:solidFill>
+                  <a:srgbClr val="4EC9B0"/>
+                </a:solidFill>
+                <a:latin typeface="Courier New" pitchFamily="34" charset="0"/>
+                <a:ea typeface="Courier New" pitchFamily="34" charset="-122"/>
+                <a:cs typeface="Courier New" pitchFamily="34" charset="-120"/>
+              </a:rPr>
+              <a:t>Pedidos</a:t>
+            </a:r>
+            <a:pPr indent="0" marL="0">
+              <a:buNone/>
+            </a:pPr>
+            <a:r>
+              <a:rPr lang="en-US" sz="1200" dirty="0">
+                <a:solidFill>
+                  <a:srgbClr val="CCCCCC"/>
+                </a:solidFill>
+                <a:latin typeface="Courier New" pitchFamily="34" charset="0"/>
+                <a:ea typeface="Courier New" pitchFamily="34" charset="-122"/>
+                <a:cs typeface="Courier New" pitchFamily="34" charset="-120"/>
+              </a:rPr>
+              <a:t>.</a:t>
+            </a:r>
+            <a:pPr indent="0" marL="0">
+              <a:buNone/>
+            </a:pPr>
+            <a:r>
+              <a:rPr lang="en-US" sz="1200" dirty="0">
+                <a:solidFill>
+                  <a:srgbClr val="9CDCFE"/>
+                </a:solidFill>
+                <a:latin typeface="Courier New" pitchFamily="34" charset="0"/>
+                <a:ea typeface="Courier New" pitchFamily="34" charset="-122"/>
+                <a:cs typeface="Courier New" pitchFamily="34" charset="-120"/>
+              </a:rPr>
+              <a:t>drafts</a:t>
+            </a:r>
+            <a:pPr indent="0" marL="0">
+              <a:buNone/>
+            </a:pPr>
+            <a:r>
+              <a:rPr lang="en-US" sz="1200" dirty="0">
+                <a:solidFill>
+                  <a:srgbClr val="CCCCCC"/>
+                </a:solidFill>
+                <a:latin typeface="Courier New" pitchFamily="34" charset="0"/>
+                <a:ea typeface="Courier New" pitchFamily="34" charset="-122"/>
+                <a:cs typeface="Courier New" pitchFamily="34" charset="-120"/>
+              </a:rPr>
+              <a:t>, </a:t>
+            </a:r>
+            <a:pPr indent="0" marL="0">
+              <a:buNone/>
+            </a:pPr>
+            <a:r>
+              <a:rPr lang="en-US" sz="1200" dirty="0">
+                <a:solidFill>
+                  <a:srgbClr val="569CD6"/>
+                </a:solidFill>
+                <a:latin typeface="Courier New" pitchFamily="34" charset="0"/>
+                <a:ea typeface="Courier New" pitchFamily="34" charset="-122"/>
+                <a:cs typeface="Courier New" pitchFamily="34" charset="-120"/>
+              </a:rPr>
+              <a:t>async</a:t>
+            </a:r>
+            <a:pPr indent="0" marL="0">
+              <a:buNone/>
+            </a:pPr>
+            <a:r>
+              <a:rPr lang="en-US" sz="1200" dirty="0">
+                <a:solidFill>
+                  <a:srgbClr val="CCCCCC"/>
+                </a:solidFill>
+                <a:latin typeface="Courier New" pitchFamily="34" charset="0"/>
+                <a:ea typeface="Courier New" pitchFamily="34" charset="-122"/>
+                <a:cs typeface="Courier New" pitchFamily="34" charset="-120"/>
+              </a:rPr>
+              <a:t> </a:t>
+            </a:r>
+            <a:pPr indent="0" marL="0">
+              <a:buNone/>
+            </a:pPr>
+            <a:r>
+              <a:rPr lang="en-US" sz="1200" dirty="0">
+                <a:solidFill>
+                  <a:srgbClr val="9CDCFE"/>
+                </a:solidFill>
+                <a:latin typeface="Courier New" pitchFamily="34" charset="0"/>
+                <a:ea typeface="Courier New" pitchFamily="34" charset="-122"/>
+                <a:cs typeface="Courier New" pitchFamily="34" charset="-120"/>
+              </a:rPr>
+              <a:t>req</a:t>
+            </a:r>
+            <a:pPr indent="0" marL="0">
+              <a:buNone/>
+            </a:pPr>
+            <a:r>
+              <a:rPr lang="en-US" sz="1200" dirty="0">
+                <a:solidFill>
+                  <a:srgbClr val="CCCCCC"/>
+                </a:solidFill>
+                <a:latin typeface="Courier New" pitchFamily="34" charset="0"/>
+                <a:ea typeface="Courier New" pitchFamily="34" charset="-122"/>
+                <a:cs typeface="Courier New" pitchFamily="34" charset="-120"/>
+              </a:rPr>
+              <a:t> =&gt; </a:t>
+            </a:r>
+            <a:pPr indent="0" marL="0">
+              <a:buNone/>
+            </a:pPr>
+            <a:r>
+              <a:rPr lang="en-US" sz="1200" dirty="0">
+                <a:solidFill>
+                  <a:srgbClr val="FFD700"/>
+                </a:solidFill>
+                <a:latin typeface="Courier New" pitchFamily="34" charset="0"/>
+                <a:ea typeface="Courier New" pitchFamily="34" charset="-122"/>
+                <a:cs typeface="Courier New" pitchFamily="34" charset="-120"/>
+              </a:rPr>
+              <a:t>{</a:t>
             </a:r>
             <a:endParaRPr lang="en-US" sz="1200" dirty="0"/>
           </a:p>
@@ -9419,13 +10726,97 @@
             <a:r>
               <a:rPr lang="en-US" sz="1200" dirty="0">
                 <a:solidFill>
-                  <a:srgbClr val="EAECEE"/>
-                </a:solidFill>
-                <a:latin typeface="Courier New" pitchFamily="34" charset="0"/>
-                <a:ea typeface="Courier New" pitchFamily="34" charset="-122"/>
-                <a:cs typeface="Courier New" pitchFamily="34" charset="-120"/>
-              </a:rPr>
-              <a:t>      removerCamposControlados(req.data)</a:t>
+                  <a:srgbClr val="CCCCCC"/>
+                </a:solidFill>
+                <a:latin typeface="Courier New" pitchFamily="34" charset="0"/>
+                <a:ea typeface="Courier New" pitchFamily="34" charset="-122"/>
+                <a:cs typeface="Courier New" pitchFamily="34" charset="-120"/>
+              </a:rPr>
+              <a:t>      </a:t>
+            </a:r>
+            <a:pPr indent="0" marL="0">
+              <a:buNone/>
+            </a:pPr>
+            <a:r>
+              <a:rPr lang="en-US" sz="1200" dirty="0">
+                <a:solidFill>
+                  <a:srgbClr val="DCDCAA"/>
+                </a:solidFill>
+                <a:latin typeface="Courier New" pitchFamily="34" charset="0"/>
+                <a:ea typeface="Courier New" pitchFamily="34" charset="-122"/>
+                <a:cs typeface="Courier New" pitchFamily="34" charset="-120"/>
+              </a:rPr>
+              <a:t>removerCamposControlados</a:t>
+            </a:r>
+            <a:pPr indent="0" marL="0">
+              <a:buNone/>
+            </a:pPr>
+            <a:r>
+              <a:rPr lang="en-US" sz="1200" dirty="0">
+                <a:solidFill>
+                  <a:srgbClr val="DA70D6"/>
+                </a:solidFill>
+                <a:latin typeface="Courier New" pitchFamily="34" charset="0"/>
+                <a:ea typeface="Courier New" pitchFamily="34" charset="-122"/>
+                <a:cs typeface="Courier New" pitchFamily="34" charset="-120"/>
+              </a:rPr>
+              <a:t>(</a:t>
+            </a:r>
+            <a:pPr indent="0" marL="0">
+              <a:buNone/>
+            </a:pPr>
+            <a:r>
+              <a:rPr lang="en-US" sz="1200" dirty="0">
+                <a:solidFill>
+                  <a:srgbClr val="9CDCFE"/>
+                </a:solidFill>
+                <a:latin typeface="Courier New" pitchFamily="34" charset="0"/>
+                <a:ea typeface="Courier New" pitchFamily="34" charset="-122"/>
+                <a:cs typeface="Courier New" pitchFamily="34" charset="-120"/>
+              </a:rPr>
+              <a:t>req</a:t>
+            </a:r>
+            <a:pPr indent="0" marL="0">
+              <a:buNone/>
+            </a:pPr>
+            <a:r>
+              <a:rPr lang="en-US" sz="1200" dirty="0">
+                <a:solidFill>
+                  <a:srgbClr val="CCCCCC"/>
+                </a:solidFill>
+                <a:latin typeface="Courier New" pitchFamily="34" charset="0"/>
+                <a:ea typeface="Courier New" pitchFamily="34" charset="-122"/>
+                <a:cs typeface="Courier New" pitchFamily="34" charset="-120"/>
+              </a:rPr>
+              <a:t>.</a:t>
+            </a:r>
+            <a:pPr indent="0" marL="0">
+              <a:buNone/>
+            </a:pPr>
+            <a:r>
+              <a:rPr lang="en-US" sz="1200" dirty="0">
+                <a:solidFill>
+                  <a:srgbClr val="9CDCFE"/>
+                </a:solidFill>
+                <a:latin typeface="Courier New" pitchFamily="34" charset="0"/>
+                <a:ea typeface="Courier New" pitchFamily="34" charset="-122"/>
+                <a:cs typeface="Courier New" pitchFamily="34" charset="-120"/>
+              </a:rPr>
+              <a:t>data</a:t>
+            </a:r>
+            <a:pPr indent="0" marL="0">
+              <a:buNone/>
+            </a:pPr>
+            <a:r>
+              <a:rPr lang="en-US" sz="1200" dirty="0">
+                <a:solidFill>
+                  <a:srgbClr val="DA70D6"/>
+                </a:solidFill>
+                <a:latin typeface="Courier New" pitchFamily="34" charset="0"/>
+                <a:ea typeface="Courier New" pitchFamily="34" charset="-122"/>
+                <a:cs typeface="Courier New" pitchFamily="34" charset="-120"/>
+              </a:rPr>
+              <a:t>)</a:t>
             </a:r>
             <a:endParaRPr lang="en-US" sz="1200" dirty="0"/>
           </a:p>
@@ -9436,7 +10827,7 @@
             <a:r>
               <a:rPr lang="en-US" sz="1200" dirty="0">
                 <a:solidFill>
-                  <a:srgbClr val="EAECEE"/>
+                  <a:srgbClr val="CCCCCC"/>
                 </a:solidFill>
                 <a:latin typeface="Courier New" pitchFamily="34" charset="0"/>
                 <a:ea typeface="Courier New" pitchFamily="34" charset="-122"/>
@@ -9453,13 +10844,41 @@
             <a:r>
               <a:rPr lang="en-US" sz="1200" dirty="0">
                 <a:solidFill>
-                  <a:srgbClr val="EAECEE"/>
-                </a:solidFill>
-                <a:latin typeface="Courier New" pitchFamily="34" charset="0"/>
-                <a:ea typeface="Courier New" pitchFamily="34" charset="-122"/>
-                <a:cs typeface="Courier New" pitchFamily="34" charset="-120"/>
-              </a:rPr>
-              <a:t>    })</a:t>
+                  <a:srgbClr val="CCCCCC"/>
+                </a:solidFill>
+                <a:latin typeface="Courier New" pitchFamily="34" charset="0"/>
+                <a:ea typeface="Courier New" pitchFamily="34" charset="-122"/>
+                <a:cs typeface="Courier New" pitchFamily="34" charset="-120"/>
+              </a:rPr>
+              <a:t>    </a:t>
+            </a:r>
+            <a:pPr indent="0" marL="0">
+              <a:buNone/>
+            </a:pPr>
+            <a:r>
+              <a:rPr lang="en-US" sz="1200" dirty="0">
+                <a:solidFill>
+                  <a:srgbClr val="FFD700"/>
+                </a:solidFill>
+                <a:latin typeface="Courier New" pitchFamily="34" charset="0"/>
+                <a:ea typeface="Courier New" pitchFamily="34" charset="-122"/>
+                <a:cs typeface="Courier New" pitchFamily="34" charset="-120"/>
+              </a:rPr>
+              <a:t>}</a:t>
+            </a:r>
+            <a:pPr indent="0" marL="0">
+              <a:buNone/>
+            </a:pPr>
+            <a:r>
+              <a:rPr lang="en-US" sz="1200" dirty="0">
+                <a:solidFill>
+                  <a:srgbClr val="179FFF"/>
+                </a:solidFill>
+                <a:latin typeface="Courier New" pitchFamily="34" charset="0"/>
+                <a:ea typeface="Courier New" pitchFamily="34" charset="-122"/>
+                <a:cs typeface="Courier New" pitchFamily="34" charset="-120"/>
+              </a:rPr>
+              <a:t>)</a:t>
             </a:r>
             <a:endParaRPr lang="en-US" sz="1200" dirty="0"/>
           </a:p>
@@ -9470,13 +10889,97 @@
             <a:r>
               <a:rPr lang="en-US" sz="1200" dirty="0">
                 <a:solidFill>
-                  <a:srgbClr val="EAECEE"/>
-                </a:solidFill>
-                <a:latin typeface="Courier New" pitchFamily="34" charset="0"/>
-                <a:ea typeface="Courier New" pitchFamily="34" charset="-122"/>
-                <a:cs typeface="Courier New" pitchFamily="34" charset="-120"/>
-              </a:rPr>
-              <a:t>    return super.init()</a:t>
+                  <a:srgbClr val="CCCCCC"/>
+                </a:solidFill>
+                <a:latin typeface="Courier New" pitchFamily="34" charset="0"/>
+                <a:ea typeface="Courier New" pitchFamily="34" charset="-122"/>
+                <a:cs typeface="Courier New" pitchFamily="34" charset="-120"/>
+              </a:rPr>
+              <a:t>    </a:t>
+            </a:r>
+            <a:pPr indent="0" marL="0">
+              <a:buNone/>
+            </a:pPr>
+            <a:r>
+              <a:rPr lang="en-US" sz="1200" dirty="0">
+                <a:solidFill>
+                  <a:srgbClr val="C586C0"/>
+                </a:solidFill>
+                <a:latin typeface="Courier New" pitchFamily="34" charset="0"/>
+                <a:ea typeface="Courier New" pitchFamily="34" charset="-122"/>
+                <a:cs typeface="Courier New" pitchFamily="34" charset="-120"/>
+              </a:rPr>
+              <a:t>return</a:t>
+            </a:r>
+            <a:pPr indent="0" marL="0">
+              <a:buNone/>
+            </a:pPr>
+            <a:r>
+              <a:rPr lang="en-US" sz="1200" dirty="0">
+                <a:solidFill>
+                  <a:srgbClr val="CCCCCC"/>
+                </a:solidFill>
+                <a:latin typeface="Courier New" pitchFamily="34" charset="0"/>
+                <a:ea typeface="Courier New" pitchFamily="34" charset="-122"/>
+                <a:cs typeface="Courier New" pitchFamily="34" charset="-120"/>
+              </a:rPr>
+              <a:t> </a:t>
+            </a:r>
+            <a:pPr indent="0" marL="0">
+              <a:buNone/>
+            </a:pPr>
+            <a:r>
+              <a:rPr lang="en-US" sz="1200" dirty="0">
+                <a:solidFill>
+                  <a:srgbClr val="569CD6"/>
+                </a:solidFill>
+                <a:latin typeface="Courier New" pitchFamily="34" charset="0"/>
+                <a:ea typeface="Courier New" pitchFamily="34" charset="-122"/>
+                <a:cs typeface="Courier New" pitchFamily="34" charset="-120"/>
+              </a:rPr>
+              <a:t>super</a:t>
+            </a:r>
+            <a:pPr indent="0" marL="0">
+              <a:buNone/>
+            </a:pPr>
+            <a:r>
+              <a:rPr lang="en-US" sz="1200" dirty="0">
+                <a:solidFill>
+                  <a:srgbClr val="CCCCCC"/>
+                </a:solidFill>
+                <a:latin typeface="Courier New" pitchFamily="34" charset="0"/>
+                <a:ea typeface="Courier New" pitchFamily="34" charset="-122"/>
+                <a:cs typeface="Courier New" pitchFamily="34" charset="-120"/>
+              </a:rPr>
+              <a:t>.</a:t>
+            </a:r>
+            <a:pPr indent="0" marL="0">
+              <a:buNone/>
+            </a:pPr>
+            <a:r>
+              <a:rPr lang="en-US" sz="1200" dirty="0">
+                <a:solidFill>
+                  <a:srgbClr val="DCDCAA"/>
+                </a:solidFill>
+                <a:latin typeface="Courier New" pitchFamily="34" charset="0"/>
+                <a:ea typeface="Courier New" pitchFamily="34" charset="-122"/>
+                <a:cs typeface="Courier New" pitchFamily="34" charset="-120"/>
+              </a:rPr>
+              <a:t>init</a:t>
+            </a:r>
+            <a:pPr indent="0" marL="0">
+              <a:buNone/>
+            </a:pPr>
+            <a:r>
+              <a:rPr lang="en-US" sz="1200" dirty="0">
+                <a:solidFill>
+                  <a:srgbClr val="179FFF"/>
+                </a:solidFill>
+                <a:latin typeface="Courier New" pitchFamily="34" charset="0"/>
+                <a:ea typeface="Courier New" pitchFamily="34" charset="-122"/>
+                <a:cs typeface="Courier New" pitchFamily="34" charset="-120"/>
+              </a:rPr>
+              <a:t>()</a:t>
             </a:r>
             <a:endParaRPr lang="en-US" sz="1200" dirty="0"/>
           </a:p>
@@ -9487,13 +10990,27 @@
             <a:r>
               <a:rPr lang="en-US" sz="1200" dirty="0">
                 <a:solidFill>
-                  <a:srgbClr val="EAECEE"/>
-                </a:solidFill>
-                <a:latin typeface="Courier New" pitchFamily="34" charset="0"/>
-                <a:ea typeface="Courier New" pitchFamily="34" charset="-122"/>
-                <a:cs typeface="Courier New" pitchFamily="34" charset="-120"/>
-              </a:rPr>
-              <a:t>  }</a:t>
+                  <a:srgbClr val="CCCCCC"/>
+                </a:solidFill>
+                <a:latin typeface="Courier New" pitchFamily="34" charset="0"/>
+                <a:ea typeface="Courier New" pitchFamily="34" charset="-122"/>
+                <a:cs typeface="Courier New" pitchFamily="34" charset="-120"/>
+              </a:rPr>
+              <a:t>  </a:t>
+            </a:r>
+            <a:pPr indent="0" marL="0">
+              <a:buNone/>
+            </a:pPr>
+            <a:r>
+              <a:rPr lang="en-US" sz="1200" dirty="0">
+                <a:solidFill>
+                  <a:srgbClr val="DA70D6"/>
+                </a:solidFill>
+                <a:latin typeface="Courier New" pitchFamily="34" charset="0"/>
+                <a:ea typeface="Courier New" pitchFamily="34" charset="-122"/>
+                <a:cs typeface="Courier New" pitchFamily="34" charset="-120"/>
+              </a:rPr>
+              <a:t>}</a:t>
             </a:r>
             <a:endParaRPr lang="en-US" sz="1200" dirty="0"/>
           </a:p>
@@ -9504,7 +11021,7 @@
             <a:r>
               <a:rPr lang="en-US" sz="1200" dirty="0">
                 <a:solidFill>
-                  <a:srgbClr val="EAECEE"/>
+                  <a:srgbClr val="FFD700"/>
                 </a:solidFill>
                 <a:latin typeface="Courier New" pitchFamily="34" charset="0"/>
                 <a:ea typeface="Courier New" pitchFamily="34" charset="-122"/>
@@ -12066,9 +13583,14 @@
             </a:avLst>
           </a:prstGeom>
           <a:solidFill>
-            <a:srgbClr val="1D2D3E"/>
+            <a:srgbClr val="1F1F1F"/>
           </a:solidFill>
-          <a:ln/>
+          <a:ln w="9525">
+            <a:solidFill>
+              <a:srgbClr val="2B2B2B"/>
+            </a:solidFill>
+            <a:prstDash val="solid"/>
+          </a:ln>
           <a:effectLst>
             <a:outerShdw sx="100000" sy="100000" kx="0" ky="0" algn="bl" rotWithShape="0" blurRad="101600" dist="25400" dir="5400000">
               <a:srgbClr val="223649">
@@ -12105,13 +13627,195 @@
             <a:r>
               <a:rPr lang="en-US" sz="1200" dirty="0">
                 <a:solidFill>
-                  <a:srgbClr val="EAECEE"/>
-                </a:solidFill>
-                <a:latin typeface="Courier New" pitchFamily="34" charset="0"/>
-                <a:ea typeface="Courier New" pitchFamily="34" charset="-122"/>
-                <a:cs typeface="Courier New" pitchFamily="34" charset="-120"/>
-              </a:rPr>
-              <a:t>async function transicionarPedido(req, pedido, dados) {</a:t>
+                  <a:srgbClr val="569CD6"/>
+                </a:solidFill>
+                <a:latin typeface="Courier New" pitchFamily="34" charset="0"/>
+                <a:ea typeface="Courier New" pitchFamily="34" charset="-122"/>
+                <a:cs typeface="Courier New" pitchFamily="34" charset="-120"/>
+              </a:rPr>
+              <a:t>async</a:t>
+            </a:r>
+            <a:pPr indent="0" marL="0">
+              <a:buNone/>
+            </a:pPr>
+            <a:r>
+              <a:rPr lang="en-US" sz="1200" dirty="0">
+                <a:solidFill>
+                  <a:srgbClr val="CCCCCC"/>
+                </a:solidFill>
+                <a:latin typeface="Courier New" pitchFamily="34" charset="0"/>
+                <a:ea typeface="Courier New" pitchFamily="34" charset="-122"/>
+                <a:cs typeface="Courier New" pitchFamily="34" charset="-120"/>
+              </a:rPr>
+              <a:t> </a:t>
+            </a:r>
+            <a:pPr indent="0" marL="0">
+              <a:buNone/>
+            </a:pPr>
+            <a:r>
+              <a:rPr lang="en-US" sz="1200" dirty="0">
+                <a:solidFill>
+                  <a:srgbClr val="569CD6"/>
+                </a:solidFill>
+                <a:latin typeface="Courier New" pitchFamily="34" charset="0"/>
+                <a:ea typeface="Courier New" pitchFamily="34" charset="-122"/>
+                <a:cs typeface="Courier New" pitchFamily="34" charset="-120"/>
+              </a:rPr>
+              <a:t>function</a:t>
+            </a:r>
+            <a:pPr indent="0" marL="0">
+              <a:buNone/>
+            </a:pPr>
+            <a:r>
+              <a:rPr lang="en-US" sz="1200" dirty="0">
+                <a:solidFill>
+                  <a:srgbClr val="CCCCCC"/>
+                </a:solidFill>
+                <a:latin typeface="Courier New" pitchFamily="34" charset="0"/>
+                <a:ea typeface="Courier New" pitchFamily="34" charset="-122"/>
+                <a:cs typeface="Courier New" pitchFamily="34" charset="-120"/>
+              </a:rPr>
+              <a:t> </a:t>
+            </a:r>
+            <a:pPr indent="0" marL="0">
+              <a:buNone/>
+            </a:pPr>
+            <a:r>
+              <a:rPr lang="en-US" sz="1200" dirty="0">
+                <a:solidFill>
+                  <a:srgbClr val="DCDCAA"/>
+                </a:solidFill>
+                <a:latin typeface="Courier New" pitchFamily="34" charset="0"/>
+                <a:ea typeface="Courier New" pitchFamily="34" charset="-122"/>
+                <a:cs typeface="Courier New" pitchFamily="34" charset="-120"/>
+              </a:rPr>
+              <a:t>transicionarPedido</a:t>
+            </a:r>
+            <a:pPr indent="0" marL="0">
+              <a:buNone/>
+            </a:pPr>
+            <a:r>
+              <a:rPr lang="en-US" sz="1200" dirty="0">
+                <a:solidFill>
+                  <a:srgbClr val="FFD700"/>
+                </a:solidFill>
+                <a:latin typeface="Courier New" pitchFamily="34" charset="0"/>
+                <a:ea typeface="Courier New" pitchFamily="34" charset="-122"/>
+                <a:cs typeface="Courier New" pitchFamily="34" charset="-120"/>
+              </a:rPr>
+              <a:t>(</a:t>
+            </a:r>
+            <a:pPr indent="0" marL="0">
+              <a:buNone/>
+            </a:pPr>
+            <a:r>
+              <a:rPr lang="en-US" sz="1200" dirty="0">
+                <a:solidFill>
+                  <a:srgbClr val="9CDCFE"/>
+                </a:solidFill>
+                <a:latin typeface="Courier New" pitchFamily="34" charset="0"/>
+                <a:ea typeface="Courier New" pitchFamily="34" charset="-122"/>
+                <a:cs typeface="Courier New" pitchFamily="34" charset="-120"/>
+              </a:rPr>
+              <a:t>req</a:t>
+            </a:r>
+            <a:pPr indent="0" marL="0">
+              <a:buNone/>
+            </a:pPr>
+            <a:r>
+              <a:rPr lang="en-US" sz="1200" dirty="0">
+                <a:solidFill>
+                  <a:srgbClr val="CCCCCC"/>
+                </a:solidFill>
+                <a:latin typeface="Courier New" pitchFamily="34" charset="0"/>
+                <a:ea typeface="Courier New" pitchFamily="34" charset="-122"/>
+                <a:cs typeface="Courier New" pitchFamily="34" charset="-120"/>
+              </a:rPr>
+              <a:t>, </a:t>
+            </a:r>
+            <a:pPr indent="0" marL="0">
+              <a:buNone/>
+            </a:pPr>
+            <a:r>
+              <a:rPr lang="en-US" sz="1200" dirty="0">
+                <a:solidFill>
+                  <a:srgbClr val="9CDCFE"/>
+                </a:solidFill>
+                <a:latin typeface="Courier New" pitchFamily="34" charset="0"/>
+                <a:ea typeface="Courier New" pitchFamily="34" charset="-122"/>
+                <a:cs typeface="Courier New" pitchFamily="34" charset="-120"/>
+              </a:rPr>
+              <a:t>pedido</a:t>
+            </a:r>
+            <a:pPr indent="0" marL="0">
+              <a:buNone/>
+            </a:pPr>
+            <a:r>
+              <a:rPr lang="en-US" sz="1200" dirty="0">
+                <a:solidFill>
+                  <a:srgbClr val="CCCCCC"/>
+                </a:solidFill>
+                <a:latin typeface="Courier New" pitchFamily="34" charset="0"/>
+                <a:ea typeface="Courier New" pitchFamily="34" charset="-122"/>
+                <a:cs typeface="Courier New" pitchFamily="34" charset="-120"/>
+              </a:rPr>
+              <a:t>, </a:t>
+            </a:r>
+            <a:pPr indent="0" marL="0">
+              <a:buNone/>
+            </a:pPr>
+            <a:r>
+              <a:rPr lang="en-US" sz="1200" dirty="0">
+                <a:solidFill>
+                  <a:srgbClr val="9CDCFE"/>
+                </a:solidFill>
+                <a:latin typeface="Courier New" pitchFamily="34" charset="0"/>
+                <a:ea typeface="Courier New" pitchFamily="34" charset="-122"/>
+                <a:cs typeface="Courier New" pitchFamily="34" charset="-120"/>
+              </a:rPr>
+              <a:t>dados</a:t>
+            </a:r>
+            <a:pPr indent="0" marL="0">
+              <a:buNone/>
+            </a:pPr>
+            <a:r>
+              <a:rPr lang="en-US" sz="1200" dirty="0">
+                <a:solidFill>
+                  <a:srgbClr val="FFD700"/>
+                </a:solidFill>
+                <a:latin typeface="Courier New" pitchFamily="34" charset="0"/>
+                <a:ea typeface="Courier New" pitchFamily="34" charset="-122"/>
+                <a:cs typeface="Courier New" pitchFamily="34" charset="-120"/>
+              </a:rPr>
+              <a:t>)</a:t>
+            </a:r>
+            <a:pPr indent="0" marL="0">
+              <a:buNone/>
+            </a:pPr>
+            <a:r>
+              <a:rPr lang="en-US" sz="1200" dirty="0">
+                <a:solidFill>
+                  <a:srgbClr val="CCCCCC"/>
+                </a:solidFill>
+                <a:latin typeface="Courier New" pitchFamily="34" charset="0"/>
+                <a:ea typeface="Courier New" pitchFamily="34" charset="-122"/>
+                <a:cs typeface="Courier New" pitchFamily="34" charset="-120"/>
+              </a:rPr>
+              <a:t> </a:t>
+            </a:r>
+            <a:pPr indent="0" marL="0">
+              <a:buNone/>
+            </a:pPr>
+            <a:r>
+              <a:rPr lang="en-US" sz="1200" dirty="0">
+                <a:solidFill>
+                  <a:srgbClr val="FFD700"/>
+                </a:solidFill>
+                <a:latin typeface="Courier New" pitchFamily="34" charset="0"/>
+                <a:ea typeface="Courier New" pitchFamily="34" charset="-122"/>
+                <a:cs typeface="Courier New" pitchFamily="34" charset="-120"/>
+              </a:rPr>
+              <a:t>{</a:t>
             </a:r>
             <a:endParaRPr lang="en-US" sz="1200" dirty="0"/>
           </a:p>
@@ -12122,13 +13826,279 @@
             <a:r>
               <a:rPr lang="en-US" sz="1200" dirty="0">
                 <a:solidFill>
-                  <a:srgbClr val="EAECEE"/>
-                </a:solidFill>
-                <a:latin typeface="Courier New" pitchFamily="34" charset="0"/>
-                <a:ea typeface="Courier New" pitchFamily="34" charset="-122"/>
-                <a:cs typeface="Courier New" pitchFamily="34" charset="-120"/>
-              </a:rPr>
-              <a:t>  const alterados = await UPDATE(Pedidos).with(dados).where({</a:t>
+                  <a:srgbClr val="CCCCCC"/>
+                </a:solidFill>
+                <a:latin typeface="Courier New" pitchFamily="34" charset="0"/>
+                <a:ea typeface="Courier New" pitchFamily="34" charset="-122"/>
+                <a:cs typeface="Courier New" pitchFamily="34" charset="-120"/>
+              </a:rPr>
+              <a:t>  </a:t>
+            </a:r>
+            <a:pPr indent="0" marL="0">
+              <a:buNone/>
+            </a:pPr>
+            <a:r>
+              <a:rPr lang="en-US" sz="1200" dirty="0">
+                <a:solidFill>
+                  <a:srgbClr val="569CD6"/>
+                </a:solidFill>
+                <a:latin typeface="Courier New" pitchFamily="34" charset="0"/>
+                <a:ea typeface="Courier New" pitchFamily="34" charset="-122"/>
+                <a:cs typeface="Courier New" pitchFamily="34" charset="-120"/>
+              </a:rPr>
+              <a:t>const</a:t>
+            </a:r>
+            <a:pPr indent="0" marL="0">
+              <a:buNone/>
+            </a:pPr>
+            <a:r>
+              <a:rPr lang="en-US" sz="1200" dirty="0">
+                <a:solidFill>
+                  <a:srgbClr val="CCCCCC"/>
+                </a:solidFill>
+                <a:latin typeface="Courier New" pitchFamily="34" charset="0"/>
+                <a:ea typeface="Courier New" pitchFamily="34" charset="-122"/>
+                <a:cs typeface="Courier New" pitchFamily="34" charset="-120"/>
+              </a:rPr>
+              <a:t> </a:t>
+            </a:r>
+            <a:pPr indent="0" marL="0">
+              <a:buNone/>
+            </a:pPr>
+            <a:r>
+              <a:rPr lang="en-US" sz="1200" dirty="0">
+                <a:solidFill>
+                  <a:srgbClr val="9CDCFE"/>
+                </a:solidFill>
+                <a:latin typeface="Courier New" pitchFamily="34" charset="0"/>
+                <a:ea typeface="Courier New" pitchFamily="34" charset="-122"/>
+                <a:cs typeface="Courier New" pitchFamily="34" charset="-120"/>
+              </a:rPr>
+              <a:t>alterados</a:t>
+            </a:r>
+            <a:pPr indent="0" marL="0">
+              <a:buNone/>
+            </a:pPr>
+            <a:r>
+              <a:rPr lang="en-US" sz="1200" dirty="0">
+                <a:solidFill>
+                  <a:srgbClr val="CCCCCC"/>
+                </a:solidFill>
+                <a:latin typeface="Courier New" pitchFamily="34" charset="0"/>
+                <a:ea typeface="Courier New" pitchFamily="34" charset="-122"/>
+                <a:cs typeface="Courier New" pitchFamily="34" charset="-120"/>
+              </a:rPr>
+              <a:t> = </a:t>
+            </a:r>
+            <a:pPr indent="0" marL="0">
+              <a:buNone/>
+            </a:pPr>
+            <a:r>
+              <a:rPr lang="en-US" sz="1200" dirty="0">
+                <a:solidFill>
+                  <a:srgbClr val="C586C0"/>
+                </a:solidFill>
+                <a:latin typeface="Courier New" pitchFamily="34" charset="0"/>
+                <a:ea typeface="Courier New" pitchFamily="34" charset="-122"/>
+                <a:cs typeface="Courier New" pitchFamily="34" charset="-120"/>
+              </a:rPr>
+              <a:t>await</a:t>
+            </a:r>
+            <a:pPr indent="0" marL="0">
+              <a:buNone/>
+            </a:pPr>
+            <a:r>
+              <a:rPr lang="en-US" sz="1200" dirty="0">
+                <a:solidFill>
+                  <a:srgbClr val="CCCCCC"/>
+                </a:solidFill>
+                <a:latin typeface="Courier New" pitchFamily="34" charset="0"/>
+                <a:ea typeface="Courier New" pitchFamily="34" charset="-122"/>
+                <a:cs typeface="Courier New" pitchFamily="34" charset="-120"/>
+              </a:rPr>
+              <a:t> </a:t>
+            </a:r>
+            <a:pPr indent="0" marL="0">
+              <a:buNone/>
+            </a:pPr>
+            <a:r>
+              <a:rPr lang="en-US" sz="1200" dirty="0">
+                <a:solidFill>
+                  <a:srgbClr val="DCDCAA"/>
+                </a:solidFill>
+                <a:latin typeface="Courier New" pitchFamily="34" charset="0"/>
+                <a:ea typeface="Courier New" pitchFamily="34" charset="-122"/>
+                <a:cs typeface="Courier New" pitchFamily="34" charset="-120"/>
+              </a:rPr>
+              <a:t>UPDATE</a:t>
+            </a:r>
+            <a:pPr indent="0" marL="0">
+              <a:buNone/>
+            </a:pPr>
+            <a:r>
+              <a:rPr lang="en-US" sz="1200" dirty="0">
+                <a:solidFill>
+                  <a:srgbClr val="DA70D6"/>
+                </a:solidFill>
+                <a:latin typeface="Courier New" pitchFamily="34" charset="0"/>
+                <a:ea typeface="Courier New" pitchFamily="34" charset="-122"/>
+                <a:cs typeface="Courier New" pitchFamily="34" charset="-120"/>
+              </a:rPr>
+              <a:t>(</a:t>
+            </a:r>
+            <a:pPr indent="0" marL="0">
+              <a:buNone/>
+            </a:pPr>
+            <a:r>
+              <a:rPr lang="en-US" sz="1200" dirty="0">
+                <a:solidFill>
+                  <a:srgbClr val="4EC9B0"/>
+                </a:solidFill>
+                <a:latin typeface="Courier New" pitchFamily="34" charset="0"/>
+                <a:ea typeface="Courier New" pitchFamily="34" charset="-122"/>
+                <a:cs typeface="Courier New" pitchFamily="34" charset="-120"/>
+              </a:rPr>
+              <a:t>Pedidos</a:t>
+            </a:r>
+            <a:pPr indent="0" marL="0">
+              <a:buNone/>
+            </a:pPr>
+            <a:r>
+              <a:rPr lang="en-US" sz="1200" dirty="0">
+                <a:solidFill>
+                  <a:srgbClr val="DA70D6"/>
+                </a:solidFill>
+                <a:latin typeface="Courier New" pitchFamily="34" charset="0"/>
+                <a:ea typeface="Courier New" pitchFamily="34" charset="-122"/>
+                <a:cs typeface="Courier New" pitchFamily="34" charset="-120"/>
+              </a:rPr>
+              <a:t>)</a:t>
+            </a:r>
+            <a:pPr indent="0" marL="0">
+              <a:buNone/>
+            </a:pPr>
+            <a:r>
+              <a:rPr lang="en-US" sz="1200" dirty="0">
+                <a:solidFill>
+                  <a:srgbClr val="CCCCCC"/>
+                </a:solidFill>
+                <a:latin typeface="Courier New" pitchFamily="34" charset="0"/>
+                <a:ea typeface="Courier New" pitchFamily="34" charset="-122"/>
+                <a:cs typeface="Courier New" pitchFamily="34" charset="-120"/>
+              </a:rPr>
+              <a:t>.</a:t>
+            </a:r>
+            <a:pPr indent="0" marL="0">
+              <a:buNone/>
+            </a:pPr>
+            <a:r>
+              <a:rPr lang="en-US" sz="1200" dirty="0">
+                <a:solidFill>
+                  <a:srgbClr val="DCDCAA"/>
+                </a:solidFill>
+                <a:latin typeface="Courier New" pitchFamily="34" charset="0"/>
+                <a:ea typeface="Courier New" pitchFamily="34" charset="-122"/>
+                <a:cs typeface="Courier New" pitchFamily="34" charset="-120"/>
+              </a:rPr>
+              <a:t>with</a:t>
+            </a:r>
+            <a:pPr indent="0" marL="0">
+              <a:buNone/>
+            </a:pPr>
+            <a:r>
+              <a:rPr lang="en-US" sz="1200" dirty="0">
+                <a:solidFill>
+                  <a:srgbClr val="DA70D6"/>
+                </a:solidFill>
+                <a:latin typeface="Courier New" pitchFamily="34" charset="0"/>
+                <a:ea typeface="Courier New" pitchFamily="34" charset="-122"/>
+                <a:cs typeface="Courier New" pitchFamily="34" charset="-120"/>
+              </a:rPr>
+              <a:t>(</a:t>
+            </a:r>
+            <a:pPr indent="0" marL="0">
+              <a:buNone/>
+            </a:pPr>
+            <a:r>
+              <a:rPr lang="en-US" sz="1200" dirty="0">
+                <a:solidFill>
+                  <a:srgbClr val="9CDCFE"/>
+                </a:solidFill>
+                <a:latin typeface="Courier New" pitchFamily="34" charset="0"/>
+                <a:ea typeface="Courier New" pitchFamily="34" charset="-122"/>
+                <a:cs typeface="Courier New" pitchFamily="34" charset="-120"/>
+              </a:rPr>
+              <a:t>dados</a:t>
+            </a:r>
+            <a:pPr indent="0" marL="0">
+              <a:buNone/>
+            </a:pPr>
+            <a:r>
+              <a:rPr lang="en-US" sz="1200" dirty="0">
+                <a:solidFill>
+                  <a:srgbClr val="DA70D6"/>
+                </a:solidFill>
+                <a:latin typeface="Courier New" pitchFamily="34" charset="0"/>
+                <a:ea typeface="Courier New" pitchFamily="34" charset="-122"/>
+                <a:cs typeface="Courier New" pitchFamily="34" charset="-120"/>
+              </a:rPr>
+              <a:t>)</a:t>
+            </a:r>
+            <a:pPr indent="0" marL="0">
+              <a:buNone/>
+            </a:pPr>
+            <a:r>
+              <a:rPr lang="en-US" sz="1200" dirty="0">
+                <a:solidFill>
+                  <a:srgbClr val="CCCCCC"/>
+                </a:solidFill>
+                <a:latin typeface="Courier New" pitchFamily="34" charset="0"/>
+                <a:ea typeface="Courier New" pitchFamily="34" charset="-122"/>
+                <a:cs typeface="Courier New" pitchFamily="34" charset="-120"/>
+              </a:rPr>
+              <a:t>.</a:t>
+            </a:r>
+            <a:pPr indent="0" marL="0">
+              <a:buNone/>
+            </a:pPr>
+            <a:r>
+              <a:rPr lang="en-US" sz="1200" dirty="0">
+                <a:solidFill>
+                  <a:srgbClr val="DCDCAA"/>
+                </a:solidFill>
+                <a:latin typeface="Courier New" pitchFamily="34" charset="0"/>
+                <a:ea typeface="Courier New" pitchFamily="34" charset="-122"/>
+                <a:cs typeface="Courier New" pitchFamily="34" charset="-120"/>
+              </a:rPr>
+              <a:t>where</a:t>
+            </a:r>
+            <a:pPr indent="0" marL="0">
+              <a:buNone/>
+            </a:pPr>
+            <a:r>
+              <a:rPr lang="en-US" sz="1200" dirty="0">
+                <a:solidFill>
+                  <a:srgbClr val="DA70D6"/>
+                </a:solidFill>
+                <a:latin typeface="Courier New" pitchFamily="34" charset="0"/>
+                <a:ea typeface="Courier New" pitchFamily="34" charset="-122"/>
+                <a:cs typeface="Courier New" pitchFamily="34" charset="-120"/>
+              </a:rPr>
+              <a:t>(</a:t>
+            </a:r>
+            <a:pPr indent="0" marL="0">
+              <a:buNone/>
+            </a:pPr>
+            <a:r>
+              <a:rPr lang="en-US" sz="1200" dirty="0">
+                <a:solidFill>
+                  <a:srgbClr val="179FFF"/>
+                </a:solidFill>
+                <a:latin typeface="Courier New" pitchFamily="34" charset="0"/>
+                <a:ea typeface="Courier New" pitchFamily="34" charset="-122"/>
+                <a:cs typeface="Courier New" pitchFamily="34" charset="-120"/>
+              </a:rPr>
+              <a:t>{</a:t>
             </a:r>
             <a:endParaRPr lang="en-US" sz="1200" dirty="0"/>
           </a:p>
@@ -12139,13 +14109,97 @@
             <a:r>
               <a:rPr lang="en-US" sz="1200" dirty="0">
                 <a:solidFill>
-                  <a:srgbClr val="EAECEE"/>
-                </a:solidFill>
-                <a:latin typeface="Courier New" pitchFamily="34" charset="0"/>
-                <a:ea typeface="Courier New" pitchFamily="34" charset="-122"/>
-                <a:cs typeface="Courier New" pitchFamily="34" charset="-120"/>
-              </a:rPr>
-              <a:t>    ID: pedido.ID,</a:t>
+                  <a:srgbClr val="CCCCCC"/>
+                </a:solidFill>
+                <a:latin typeface="Courier New" pitchFamily="34" charset="0"/>
+                <a:ea typeface="Courier New" pitchFamily="34" charset="-122"/>
+                <a:cs typeface="Courier New" pitchFamily="34" charset="-120"/>
+              </a:rPr>
+              <a:t>    </a:t>
+            </a:r>
+            <a:pPr indent="0" marL="0">
+              <a:buNone/>
+            </a:pPr>
+            <a:r>
+              <a:rPr lang="en-US" sz="1200" dirty="0">
+                <a:solidFill>
+                  <a:srgbClr val="4FC1FF"/>
+                </a:solidFill>
+                <a:latin typeface="Courier New" pitchFamily="34" charset="0"/>
+                <a:ea typeface="Courier New" pitchFamily="34" charset="-122"/>
+                <a:cs typeface="Courier New" pitchFamily="34" charset="-120"/>
+              </a:rPr>
+              <a:t>ID</a:t>
+            </a:r>
+            <a:pPr indent="0" marL="0">
+              <a:buNone/>
+            </a:pPr>
+            <a:r>
+              <a:rPr lang="en-US" sz="1200" dirty="0">
+                <a:solidFill>
+                  <a:srgbClr val="CCCCCC"/>
+                </a:solidFill>
+                <a:latin typeface="Courier New" pitchFamily="34" charset="0"/>
+                <a:ea typeface="Courier New" pitchFamily="34" charset="-122"/>
+                <a:cs typeface="Courier New" pitchFamily="34" charset="-120"/>
+              </a:rPr>
+              <a:t>: </a:t>
+            </a:r>
+            <a:pPr indent="0" marL="0">
+              <a:buNone/>
+            </a:pPr>
+            <a:r>
+              <a:rPr lang="en-US" sz="1200" dirty="0">
+                <a:solidFill>
+                  <a:srgbClr val="9CDCFE"/>
+                </a:solidFill>
+                <a:latin typeface="Courier New" pitchFamily="34" charset="0"/>
+                <a:ea typeface="Courier New" pitchFamily="34" charset="-122"/>
+                <a:cs typeface="Courier New" pitchFamily="34" charset="-120"/>
+              </a:rPr>
+              <a:t>pedido</a:t>
+            </a:r>
+            <a:pPr indent="0" marL="0">
+              <a:buNone/>
+            </a:pPr>
+            <a:r>
+              <a:rPr lang="en-US" sz="1200" dirty="0">
+                <a:solidFill>
+                  <a:srgbClr val="CCCCCC"/>
+                </a:solidFill>
+                <a:latin typeface="Courier New" pitchFamily="34" charset="0"/>
+                <a:ea typeface="Courier New" pitchFamily="34" charset="-122"/>
+                <a:cs typeface="Courier New" pitchFamily="34" charset="-120"/>
+              </a:rPr>
+              <a:t>.</a:t>
+            </a:r>
+            <a:pPr indent="0" marL="0">
+              <a:buNone/>
+            </a:pPr>
+            <a:r>
+              <a:rPr lang="en-US" sz="1200" dirty="0">
+                <a:solidFill>
+                  <a:srgbClr val="4FC1FF"/>
+                </a:solidFill>
+                <a:latin typeface="Courier New" pitchFamily="34" charset="0"/>
+                <a:ea typeface="Courier New" pitchFamily="34" charset="-122"/>
+                <a:cs typeface="Courier New" pitchFamily="34" charset="-120"/>
+              </a:rPr>
+              <a:t>ID</a:t>
+            </a:r>
+            <a:pPr indent="0" marL="0">
+              <a:buNone/>
+            </a:pPr>
+            <a:r>
+              <a:rPr lang="en-US" sz="1200" dirty="0">
+                <a:solidFill>
+                  <a:srgbClr val="CCCCCC"/>
+                </a:solidFill>
+                <a:latin typeface="Courier New" pitchFamily="34" charset="0"/>
+                <a:ea typeface="Courier New" pitchFamily="34" charset="-122"/>
+                <a:cs typeface="Courier New" pitchFamily="34" charset="-120"/>
+              </a:rPr>
+              <a:t>,</a:t>
             </a:r>
             <a:endParaRPr lang="en-US" sz="1200" dirty="0"/>
           </a:p>
@@ -12156,13 +14210,97 @@
             <a:r>
               <a:rPr lang="en-US" sz="1200" dirty="0">
                 <a:solidFill>
-                  <a:srgbClr val="EAECEE"/>
-                </a:solidFill>
-                <a:latin typeface="Courier New" pitchFamily="34" charset="0"/>
-                <a:ea typeface="Courier New" pitchFamily="34" charset="-122"/>
-                <a:cs typeface="Courier New" pitchFamily="34" charset="-120"/>
-              </a:rPr>
-              <a:t>    statusPedido_code:    pedido.statusPedido_code,</a:t>
+                  <a:srgbClr val="CCCCCC"/>
+                </a:solidFill>
+                <a:latin typeface="Courier New" pitchFamily="34" charset="0"/>
+                <a:ea typeface="Courier New" pitchFamily="34" charset="-122"/>
+                <a:cs typeface="Courier New" pitchFamily="34" charset="-120"/>
+              </a:rPr>
+              <a:t>    </a:t>
+            </a:r>
+            <a:pPr indent="0" marL="0">
+              <a:buNone/>
+            </a:pPr>
+            <a:r>
+              <a:rPr lang="en-US" sz="1200" dirty="0">
+                <a:solidFill>
+                  <a:srgbClr val="9CDCFE"/>
+                </a:solidFill>
+                <a:latin typeface="Courier New" pitchFamily="34" charset="0"/>
+                <a:ea typeface="Courier New" pitchFamily="34" charset="-122"/>
+                <a:cs typeface="Courier New" pitchFamily="34" charset="-120"/>
+              </a:rPr>
+              <a:t>statusPedido_code</a:t>
+            </a:r>
+            <a:pPr indent="0" marL="0">
+              <a:buNone/>
+            </a:pPr>
+            <a:r>
+              <a:rPr lang="en-US" sz="1200" dirty="0">
+                <a:solidFill>
+                  <a:srgbClr val="CCCCCC"/>
+                </a:solidFill>
+                <a:latin typeface="Courier New" pitchFamily="34" charset="0"/>
+                <a:ea typeface="Courier New" pitchFamily="34" charset="-122"/>
+                <a:cs typeface="Courier New" pitchFamily="34" charset="-120"/>
+              </a:rPr>
+              <a:t>:    </a:t>
+            </a:r>
+            <a:pPr indent="0" marL="0">
+              <a:buNone/>
+            </a:pPr>
+            <a:r>
+              <a:rPr lang="en-US" sz="1200" dirty="0">
+                <a:solidFill>
+                  <a:srgbClr val="9CDCFE"/>
+                </a:solidFill>
+                <a:latin typeface="Courier New" pitchFamily="34" charset="0"/>
+                <a:ea typeface="Courier New" pitchFamily="34" charset="-122"/>
+                <a:cs typeface="Courier New" pitchFamily="34" charset="-120"/>
+              </a:rPr>
+              <a:t>pedido</a:t>
+            </a:r>
+            <a:pPr indent="0" marL="0">
+              <a:buNone/>
+            </a:pPr>
+            <a:r>
+              <a:rPr lang="en-US" sz="1200" dirty="0">
+                <a:solidFill>
+                  <a:srgbClr val="CCCCCC"/>
+                </a:solidFill>
+                <a:latin typeface="Courier New" pitchFamily="34" charset="0"/>
+                <a:ea typeface="Courier New" pitchFamily="34" charset="-122"/>
+                <a:cs typeface="Courier New" pitchFamily="34" charset="-120"/>
+              </a:rPr>
+              <a:t>.</a:t>
+            </a:r>
+            <a:pPr indent="0" marL="0">
+              <a:buNone/>
+            </a:pPr>
+            <a:r>
+              <a:rPr lang="en-US" sz="1200" dirty="0">
+                <a:solidFill>
+                  <a:srgbClr val="9CDCFE"/>
+                </a:solidFill>
+                <a:latin typeface="Courier New" pitchFamily="34" charset="0"/>
+                <a:ea typeface="Courier New" pitchFamily="34" charset="-122"/>
+                <a:cs typeface="Courier New" pitchFamily="34" charset="-120"/>
+              </a:rPr>
+              <a:t>statusPedido_code</a:t>
+            </a:r>
+            <a:pPr indent="0" marL="0">
+              <a:buNone/>
+            </a:pPr>
+            <a:r>
+              <a:rPr lang="en-US" sz="1200" dirty="0">
+                <a:solidFill>
+                  <a:srgbClr val="CCCCCC"/>
+                </a:solidFill>
+                <a:latin typeface="Courier New" pitchFamily="34" charset="0"/>
+                <a:ea typeface="Courier New" pitchFamily="34" charset="-122"/>
+                <a:cs typeface="Courier New" pitchFamily="34" charset="-120"/>
+              </a:rPr>
+              <a:t>,</a:t>
             </a:r>
             <a:endParaRPr lang="en-US" sz="1200" dirty="0"/>
           </a:p>
@@ -12173,13 +14311,83 @@
             <a:r>
               <a:rPr lang="en-US" sz="1200" dirty="0">
                 <a:solidFill>
-                  <a:srgbClr val="EAECEE"/>
-                </a:solidFill>
-                <a:latin typeface="Courier New" pitchFamily="34" charset="0"/>
-                <a:ea typeface="Courier New" pitchFamily="34" charset="-122"/>
-                <a:cs typeface="Courier New" pitchFamily="34" charset="-120"/>
-              </a:rPr>
-              <a:t>    statusPagamento_code: pedido.statusPagamento_code</a:t>
+                  <a:srgbClr val="CCCCCC"/>
+                </a:solidFill>
+                <a:latin typeface="Courier New" pitchFamily="34" charset="0"/>
+                <a:ea typeface="Courier New" pitchFamily="34" charset="-122"/>
+                <a:cs typeface="Courier New" pitchFamily="34" charset="-120"/>
+              </a:rPr>
+              <a:t>    </a:t>
+            </a:r>
+            <a:pPr indent="0" marL="0">
+              <a:buNone/>
+            </a:pPr>
+            <a:r>
+              <a:rPr lang="en-US" sz="1200" dirty="0">
+                <a:solidFill>
+                  <a:srgbClr val="9CDCFE"/>
+                </a:solidFill>
+                <a:latin typeface="Courier New" pitchFamily="34" charset="0"/>
+                <a:ea typeface="Courier New" pitchFamily="34" charset="-122"/>
+                <a:cs typeface="Courier New" pitchFamily="34" charset="-120"/>
+              </a:rPr>
+              <a:t>statusPagamento_code</a:t>
+            </a:r>
+            <a:pPr indent="0" marL="0">
+              <a:buNone/>
+            </a:pPr>
+            <a:r>
+              <a:rPr lang="en-US" sz="1200" dirty="0">
+                <a:solidFill>
+                  <a:srgbClr val="CCCCCC"/>
+                </a:solidFill>
+                <a:latin typeface="Courier New" pitchFamily="34" charset="0"/>
+                <a:ea typeface="Courier New" pitchFamily="34" charset="-122"/>
+                <a:cs typeface="Courier New" pitchFamily="34" charset="-120"/>
+              </a:rPr>
+              <a:t>: </a:t>
+            </a:r>
+            <a:pPr indent="0" marL="0">
+              <a:buNone/>
+            </a:pPr>
+            <a:r>
+              <a:rPr lang="en-US" sz="1200" dirty="0">
+                <a:solidFill>
+                  <a:srgbClr val="9CDCFE"/>
+                </a:solidFill>
+                <a:latin typeface="Courier New" pitchFamily="34" charset="0"/>
+                <a:ea typeface="Courier New" pitchFamily="34" charset="-122"/>
+                <a:cs typeface="Courier New" pitchFamily="34" charset="-120"/>
+              </a:rPr>
+              <a:t>pedido</a:t>
+            </a:r>
+            <a:pPr indent="0" marL="0">
+              <a:buNone/>
+            </a:pPr>
+            <a:r>
+              <a:rPr lang="en-US" sz="1200" dirty="0">
+                <a:solidFill>
+                  <a:srgbClr val="CCCCCC"/>
+                </a:solidFill>
+                <a:latin typeface="Courier New" pitchFamily="34" charset="0"/>
+                <a:ea typeface="Courier New" pitchFamily="34" charset="-122"/>
+                <a:cs typeface="Courier New" pitchFamily="34" charset="-120"/>
+              </a:rPr>
+              <a:t>.</a:t>
+            </a:r>
+            <a:pPr indent="0" marL="0">
+              <a:buNone/>
+            </a:pPr>
+            <a:r>
+              <a:rPr lang="en-US" sz="1200" dirty="0">
+                <a:solidFill>
+                  <a:srgbClr val="9CDCFE"/>
+                </a:solidFill>
+                <a:latin typeface="Courier New" pitchFamily="34" charset="0"/>
+                <a:ea typeface="Courier New" pitchFamily="34" charset="-122"/>
+                <a:cs typeface="Courier New" pitchFamily="34" charset="-120"/>
+              </a:rPr>
+              <a:t>statusPagamento_code</a:t>
             </a:r>
             <a:endParaRPr lang="en-US" sz="1200" dirty="0"/>
           </a:p>
@@ -12190,13 +14398,41 @@
             <a:r>
               <a:rPr lang="en-US" sz="1200" dirty="0">
                 <a:solidFill>
-                  <a:srgbClr val="EAECEE"/>
-                </a:solidFill>
-                <a:latin typeface="Courier New" pitchFamily="34" charset="0"/>
-                <a:ea typeface="Courier New" pitchFamily="34" charset="-122"/>
-                <a:cs typeface="Courier New" pitchFamily="34" charset="-120"/>
-              </a:rPr>
-              <a:t>  })</a:t>
+                  <a:srgbClr val="CCCCCC"/>
+                </a:solidFill>
+                <a:latin typeface="Courier New" pitchFamily="34" charset="0"/>
+                <a:ea typeface="Courier New" pitchFamily="34" charset="-122"/>
+                <a:cs typeface="Courier New" pitchFamily="34" charset="-120"/>
+              </a:rPr>
+              <a:t>  </a:t>
+            </a:r>
+            <a:pPr indent="0" marL="0">
+              <a:buNone/>
+            </a:pPr>
+            <a:r>
+              <a:rPr lang="en-US" sz="1200" dirty="0">
+                <a:solidFill>
+                  <a:srgbClr val="179FFF"/>
+                </a:solidFill>
+                <a:latin typeface="Courier New" pitchFamily="34" charset="0"/>
+                <a:ea typeface="Courier New" pitchFamily="34" charset="-122"/>
+                <a:cs typeface="Courier New" pitchFamily="34" charset="-120"/>
+              </a:rPr>
+              <a:t>}</a:t>
+            </a:r>
+            <a:pPr indent="0" marL="0">
+              <a:buNone/>
+            </a:pPr>
+            <a:r>
+              <a:rPr lang="en-US" sz="1200" dirty="0">
+                <a:solidFill>
+                  <a:srgbClr val="DA70D6"/>
+                </a:solidFill>
+                <a:latin typeface="Courier New" pitchFamily="34" charset="0"/>
+                <a:ea typeface="Courier New" pitchFamily="34" charset="-122"/>
+                <a:cs typeface="Courier New" pitchFamily="34" charset="-120"/>
+              </a:rPr>
+              <a:t>)</a:t>
             </a:r>
             <a:endParaRPr lang="en-US" sz="1200" dirty="0"/>
           </a:p>
@@ -12207,13 +14443,167 @@
             <a:r>
               <a:rPr lang="en-US" sz="1200" dirty="0">
                 <a:solidFill>
-                  <a:srgbClr val="EAECEE"/>
-                </a:solidFill>
-                <a:latin typeface="Courier New" pitchFamily="34" charset="0"/>
-                <a:ea typeface="Courier New" pitchFamily="34" charset="-122"/>
-                <a:cs typeface="Courier New" pitchFamily="34" charset="-120"/>
-              </a:rPr>
-              <a:t>  if (alterados === 1) return true</a:t>
+                  <a:srgbClr val="CCCCCC"/>
+                </a:solidFill>
+                <a:latin typeface="Courier New" pitchFamily="34" charset="0"/>
+                <a:ea typeface="Courier New" pitchFamily="34" charset="-122"/>
+                <a:cs typeface="Courier New" pitchFamily="34" charset="-120"/>
+              </a:rPr>
+              <a:t>  </a:t>
+            </a:r>
+            <a:pPr indent="0" marL="0">
+              <a:buNone/>
+            </a:pPr>
+            <a:r>
+              <a:rPr lang="en-US" sz="1200" dirty="0">
+                <a:solidFill>
+                  <a:srgbClr val="C586C0"/>
+                </a:solidFill>
+                <a:latin typeface="Courier New" pitchFamily="34" charset="0"/>
+                <a:ea typeface="Courier New" pitchFamily="34" charset="-122"/>
+                <a:cs typeface="Courier New" pitchFamily="34" charset="-120"/>
+              </a:rPr>
+              <a:t>if</a:t>
+            </a:r>
+            <a:pPr indent="0" marL="0">
+              <a:buNone/>
+            </a:pPr>
+            <a:r>
+              <a:rPr lang="en-US" sz="1200" dirty="0">
+                <a:solidFill>
+                  <a:srgbClr val="CCCCCC"/>
+                </a:solidFill>
+                <a:latin typeface="Courier New" pitchFamily="34" charset="0"/>
+                <a:ea typeface="Courier New" pitchFamily="34" charset="-122"/>
+                <a:cs typeface="Courier New" pitchFamily="34" charset="-120"/>
+              </a:rPr>
+              <a:t> </a:t>
+            </a:r>
+            <a:pPr indent="0" marL="0">
+              <a:buNone/>
+            </a:pPr>
+            <a:r>
+              <a:rPr lang="en-US" sz="1200" dirty="0">
+                <a:solidFill>
+                  <a:srgbClr val="DA70D6"/>
+                </a:solidFill>
+                <a:latin typeface="Courier New" pitchFamily="34" charset="0"/>
+                <a:ea typeface="Courier New" pitchFamily="34" charset="-122"/>
+                <a:cs typeface="Courier New" pitchFamily="34" charset="-120"/>
+              </a:rPr>
+              <a:t>(</a:t>
+            </a:r>
+            <a:pPr indent="0" marL="0">
+              <a:buNone/>
+            </a:pPr>
+            <a:r>
+              <a:rPr lang="en-US" sz="1200" dirty="0">
+                <a:solidFill>
+                  <a:srgbClr val="9CDCFE"/>
+                </a:solidFill>
+                <a:latin typeface="Courier New" pitchFamily="34" charset="0"/>
+                <a:ea typeface="Courier New" pitchFamily="34" charset="-122"/>
+                <a:cs typeface="Courier New" pitchFamily="34" charset="-120"/>
+              </a:rPr>
+              <a:t>alterados</a:t>
+            </a:r>
+            <a:pPr indent="0" marL="0">
+              <a:buNone/>
+            </a:pPr>
+            <a:r>
+              <a:rPr lang="en-US" sz="1200" dirty="0">
+                <a:solidFill>
+                  <a:srgbClr val="CCCCCC"/>
+                </a:solidFill>
+                <a:latin typeface="Courier New" pitchFamily="34" charset="0"/>
+                <a:ea typeface="Courier New" pitchFamily="34" charset="-122"/>
+                <a:cs typeface="Courier New" pitchFamily="34" charset="-120"/>
+              </a:rPr>
+              <a:t> === </a:t>
+            </a:r>
+            <a:pPr indent="0" marL="0">
+              <a:buNone/>
+            </a:pPr>
+            <a:r>
+              <a:rPr lang="en-US" sz="1200" dirty="0">
+                <a:solidFill>
+                  <a:srgbClr val="B5CEA8"/>
+                </a:solidFill>
+                <a:latin typeface="Courier New" pitchFamily="34" charset="0"/>
+                <a:ea typeface="Courier New" pitchFamily="34" charset="-122"/>
+                <a:cs typeface="Courier New" pitchFamily="34" charset="-120"/>
+              </a:rPr>
+              <a:t>1</a:t>
+            </a:r>
+            <a:pPr indent="0" marL="0">
+              <a:buNone/>
+            </a:pPr>
+            <a:r>
+              <a:rPr lang="en-US" sz="1200" dirty="0">
+                <a:solidFill>
+                  <a:srgbClr val="DA70D6"/>
+                </a:solidFill>
+                <a:latin typeface="Courier New" pitchFamily="34" charset="0"/>
+                <a:ea typeface="Courier New" pitchFamily="34" charset="-122"/>
+                <a:cs typeface="Courier New" pitchFamily="34" charset="-120"/>
+              </a:rPr>
+              <a:t>)</a:t>
+            </a:r>
+            <a:pPr indent="0" marL="0">
+              <a:buNone/>
+            </a:pPr>
+            <a:r>
+              <a:rPr lang="en-US" sz="1200" dirty="0">
+                <a:solidFill>
+                  <a:srgbClr val="CCCCCC"/>
+                </a:solidFill>
+                <a:latin typeface="Courier New" pitchFamily="34" charset="0"/>
+                <a:ea typeface="Courier New" pitchFamily="34" charset="-122"/>
+                <a:cs typeface="Courier New" pitchFamily="34" charset="-120"/>
+              </a:rPr>
+              <a:t> </a:t>
+            </a:r>
+            <a:pPr indent="0" marL="0">
+              <a:buNone/>
+            </a:pPr>
+            <a:r>
+              <a:rPr lang="en-US" sz="1200" dirty="0">
+                <a:solidFill>
+                  <a:srgbClr val="C586C0"/>
+                </a:solidFill>
+                <a:latin typeface="Courier New" pitchFamily="34" charset="0"/>
+                <a:ea typeface="Courier New" pitchFamily="34" charset="-122"/>
+                <a:cs typeface="Courier New" pitchFamily="34" charset="-120"/>
+              </a:rPr>
+              <a:t>return</a:t>
+            </a:r>
+            <a:pPr indent="0" marL="0">
+              <a:buNone/>
+            </a:pPr>
+            <a:r>
+              <a:rPr lang="en-US" sz="1200" dirty="0">
+                <a:solidFill>
+                  <a:srgbClr val="CCCCCC"/>
+                </a:solidFill>
+                <a:latin typeface="Courier New" pitchFamily="34" charset="0"/>
+                <a:ea typeface="Courier New" pitchFamily="34" charset="-122"/>
+                <a:cs typeface="Courier New" pitchFamily="34" charset="-120"/>
+              </a:rPr>
+              <a:t> </a:t>
+            </a:r>
+            <a:pPr indent="0" marL="0">
+              <a:buNone/>
+            </a:pPr>
+            <a:r>
+              <a:rPr lang="en-US" sz="1200" dirty="0">
+                <a:solidFill>
+                  <a:srgbClr val="569CD6"/>
+                </a:solidFill>
+                <a:latin typeface="Courier New" pitchFamily="34" charset="0"/>
+                <a:ea typeface="Courier New" pitchFamily="34" charset="-122"/>
+                <a:cs typeface="Courier New" pitchFamily="34" charset="-120"/>
+              </a:rPr>
+              <a:t>true</a:t>
             </a:r>
             <a:endParaRPr lang="en-US" sz="1200" dirty="0"/>
           </a:p>
@@ -12224,13 +14614,125 @@
             <a:r>
               <a:rPr lang="en-US" sz="1200" dirty="0">
                 <a:solidFill>
-                  <a:srgbClr val="EAECEE"/>
-                </a:solidFill>
-                <a:latin typeface="Courier New" pitchFamily="34" charset="0"/>
-                <a:ea typeface="Courier New" pitchFamily="34" charset="-122"/>
-                <a:cs typeface="Courier New" pitchFamily="34" charset="-120"/>
-              </a:rPr>
-              <a:t>  erro(req, 409, 'PEDIDO_ALTERADO_CONCORRENTE')</a:t>
+                  <a:srgbClr val="CCCCCC"/>
+                </a:solidFill>
+                <a:latin typeface="Courier New" pitchFamily="34" charset="0"/>
+                <a:ea typeface="Courier New" pitchFamily="34" charset="-122"/>
+                <a:cs typeface="Courier New" pitchFamily="34" charset="-120"/>
+              </a:rPr>
+              <a:t>  </a:t>
+            </a:r>
+            <a:pPr indent="0" marL="0">
+              <a:buNone/>
+            </a:pPr>
+            <a:r>
+              <a:rPr lang="en-US" sz="1200" dirty="0">
+                <a:solidFill>
+                  <a:srgbClr val="DCDCAA"/>
+                </a:solidFill>
+                <a:latin typeface="Courier New" pitchFamily="34" charset="0"/>
+                <a:ea typeface="Courier New" pitchFamily="34" charset="-122"/>
+                <a:cs typeface="Courier New" pitchFamily="34" charset="-120"/>
+              </a:rPr>
+              <a:t>erro</a:t>
+            </a:r>
+            <a:pPr indent="0" marL="0">
+              <a:buNone/>
+            </a:pPr>
+            <a:r>
+              <a:rPr lang="en-US" sz="1200" dirty="0">
+                <a:solidFill>
+                  <a:srgbClr val="DA70D6"/>
+                </a:solidFill>
+                <a:latin typeface="Courier New" pitchFamily="34" charset="0"/>
+                <a:ea typeface="Courier New" pitchFamily="34" charset="-122"/>
+                <a:cs typeface="Courier New" pitchFamily="34" charset="-120"/>
+              </a:rPr>
+              <a:t>(</a:t>
+            </a:r>
+            <a:pPr indent="0" marL="0">
+              <a:buNone/>
+            </a:pPr>
+            <a:r>
+              <a:rPr lang="en-US" sz="1200" dirty="0">
+                <a:solidFill>
+                  <a:srgbClr val="9CDCFE"/>
+                </a:solidFill>
+                <a:latin typeface="Courier New" pitchFamily="34" charset="0"/>
+                <a:ea typeface="Courier New" pitchFamily="34" charset="-122"/>
+                <a:cs typeface="Courier New" pitchFamily="34" charset="-120"/>
+              </a:rPr>
+              <a:t>req</a:t>
+            </a:r>
+            <a:pPr indent="0" marL="0">
+              <a:buNone/>
+            </a:pPr>
+            <a:r>
+              <a:rPr lang="en-US" sz="1200" dirty="0">
+                <a:solidFill>
+                  <a:srgbClr val="CCCCCC"/>
+                </a:solidFill>
+                <a:latin typeface="Courier New" pitchFamily="34" charset="0"/>
+                <a:ea typeface="Courier New" pitchFamily="34" charset="-122"/>
+                <a:cs typeface="Courier New" pitchFamily="34" charset="-120"/>
+              </a:rPr>
+              <a:t>, </a:t>
+            </a:r>
+            <a:pPr indent="0" marL="0">
+              <a:buNone/>
+            </a:pPr>
+            <a:r>
+              <a:rPr lang="en-US" sz="1200" dirty="0">
+                <a:solidFill>
+                  <a:srgbClr val="B5CEA8"/>
+                </a:solidFill>
+                <a:latin typeface="Courier New" pitchFamily="34" charset="0"/>
+                <a:ea typeface="Courier New" pitchFamily="34" charset="-122"/>
+                <a:cs typeface="Courier New" pitchFamily="34" charset="-120"/>
+              </a:rPr>
+              <a:t>409</a:t>
+            </a:r>
+            <a:pPr indent="0" marL="0">
+              <a:buNone/>
+            </a:pPr>
+            <a:r>
+              <a:rPr lang="en-US" sz="1200" dirty="0">
+                <a:solidFill>
+                  <a:srgbClr val="CCCCCC"/>
+                </a:solidFill>
+                <a:latin typeface="Courier New" pitchFamily="34" charset="0"/>
+                <a:ea typeface="Courier New" pitchFamily="34" charset="-122"/>
+                <a:cs typeface="Courier New" pitchFamily="34" charset="-120"/>
+              </a:rPr>
+              <a:t>, </a:t>
+            </a:r>
+            <a:pPr indent="0" marL="0">
+              <a:buNone/>
+            </a:pPr>
+            <a:r>
+              <a:rPr lang="en-US" sz="1200" dirty="0">
+                <a:solidFill>
+                  <a:srgbClr val="CE9178"/>
+                </a:solidFill>
+                <a:latin typeface="Courier New" pitchFamily="34" charset="0"/>
+                <a:ea typeface="Courier New" pitchFamily="34" charset="-122"/>
+                <a:cs typeface="Courier New" pitchFamily="34" charset="-120"/>
+              </a:rPr>
+              <a:t>'PEDIDO_ALTERADO_CONCORRENTE'</a:t>
+            </a:r>
+            <a:pPr indent="0" marL="0">
+              <a:buNone/>
+            </a:pPr>
+            <a:r>
+              <a:rPr lang="en-US" sz="1200" dirty="0">
+                <a:solidFill>
+                  <a:srgbClr val="DA70D6"/>
+                </a:solidFill>
+                <a:latin typeface="Courier New" pitchFamily="34" charset="0"/>
+                <a:ea typeface="Courier New" pitchFamily="34" charset="-122"/>
+                <a:cs typeface="Courier New" pitchFamily="34" charset="-120"/>
+              </a:rPr>
+              <a:t>)</a:t>
             </a:r>
             <a:endParaRPr lang="en-US" sz="1200" dirty="0"/>
           </a:p>
@@ -12241,13 +14743,55 @@
             <a:r>
               <a:rPr lang="en-US" sz="1200" dirty="0">
                 <a:solidFill>
-                  <a:srgbClr val="EAECEE"/>
-                </a:solidFill>
-                <a:latin typeface="Courier New" pitchFamily="34" charset="0"/>
-                <a:ea typeface="Courier New" pitchFamily="34" charset="-122"/>
-                <a:cs typeface="Courier New" pitchFamily="34" charset="-120"/>
-              </a:rPr>
-              <a:t>  return false</a:t>
+                  <a:srgbClr val="CCCCCC"/>
+                </a:solidFill>
+                <a:latin typeface="Courier New" pitchFamily="34" charset="0"/>
+                <a:ea typeface="Courier New" pitchFamily="34" charset="-122"/>
+                <a:cs typeface="Courier New" pitchFamily="34" charset="-120"/>
+              </a:rPr>
+              <a:t>  </a:t>
+            </a:r>
+            <a:pPr indent="0" marL="0">
+              <a:buNone/>
+            </a:pPr>
+            <a:r>
+              <a:rPr lang="en-US" sz="1200" dirty="0">
+                <a:solidFill>
+                  <a:srgbClr val="C586C0"/>
+                </a:solidFill>
+                <a:latin typeface="Courier New" pitchFamily="34" charset="0"/>
+                <a:ea typeface="Courier New" pitchFamily="34" charset="-122"/>
+                <a:cs typeface="Courier New" pitchFamily="34" charset="-120"/>
+              </a:rPr>
+              <a:t>return</a:t>
+            </a:r>
+            <a:pPr indent="0" marL="0">
+              <a:buNone/>
+            </a:pPr>
+            <a:r>
+              <a:rPr lang="en-US" sz="1200" dirty="0">
+                <a:solidFill>
+                  <a:srgbClr val="CCCCCC"/>
+                </a:solidFill>
+                <a:latin typeface="Courier New" pitchFamily="34" charset="0"/>
+                <a:ea typeface="Courier New" pitchFamily="34" charset="-122"/>
+                <a:cs typeface="Courier New" pitchFamily="34" charset="-120"/>
+              </a:rPr>
+              <a:t> </a:t>
+            </a:r>
+            <a:pPr indent="0" marL="0">
+              <a:buNone/>
+            </a:pPr>
+            <a:r>
+              <a:rPr lang="en-US" sz="1200" dirty="0">
+                <a:solidFill>
+                  <a:srgbClr val="569CD6"/>
+                </a:solidFill>
+                <a:latin typeface="Courier New" pitchFamily="34" charset="0"/>
+                <a:ea typeface="Courier New" pitchFamily="34" charset="-122"/>
+                <a:cs typeface="Courier New" pitchFamily="34" charset="-120"/>
+              </a:rPr>
+              <a:t>false</a:t>
             </a:r>
             <a:endParaRPr lang="en-US" sz="1200" dirty="0"/>
           </a:p>
@@ -12258,7 +14802,7 @@
             <a:r>
               <a:rPr lang="en-US" sz="1200" dirty="0">
                 <a:solidFill>
-                  <a:srgbClr val="EAECEE"/>
+                  <a:srgbClr val="FFD700"/>
                 </a:solidFill>
                 <a:latin typeface="Courier New" pitchFamily="34" charset="0"/>
                 <a:ea typeface="Courier New" pitchFamily="34" charset="-122"/>

</xml_diff>